<commit_message>
feat: add Kimi/Qwen3.5VL agents, fix duplicate task IDs in interactive eval list, improve stats script
- Add Kimi K2.5 agent (mm_agents/kimi/) and run script (run_multienv_kimi_k25.py)
- Add Qwen3.5-VL agent (mm_agents/qwen35vl_agent.py) and run script (run_multienv_qwen35vl.py)
- Add corresponding taiji launch scripts for Kimi and Qwen3.5
- Fix example_final_interactive_all.json: remove 19 duplicate task IDs (ui_gen domain removed, L3_interactive_inkscape_correction_001 deduped from interactive_xt)
- Fix stats_result_by_software_and_level.py: add libreoffice_multi_njc and multiapp aliases so interactive_multiapp_* tasks are counted correctly
- Update lib_run_single.py, lib_run_interactive.py, taiji start scripts
- Update LibreOffice calc/impr/writ asset files

Co-Authored-By: Claude Sonnet 4.6 (1M context) <noreply@anthropic.com>
</commit_message>
<xml_diff>
--- a/assets/libreoffice_impr_njc/3be4747b-a8aa-4b79-8f0c-0c7326a3d169/Game Theory.pptx
+++ b/assets/libreoffice_impr_njc/3be4747b-a8aa-4b79-8f0c-0c7326a3d169/Game Theory.pptx
@@ -312,7 +312,7 @@
             <a:pPr algn="r">
               <a:buNone/>
             </a:pPr>
-            <a:fld id="{94B36BBD-3D9E-4270-AA0A-A1CEFE0F42F4}" type="slidenum">
+            <a:fld id="{EDE17819-4E61-4988-B3DC-C28BA27EED78}" type="slidenum">
               <a:rPr b="0" lang="en-HK" sz="1400" spc="-1" strike="noStrike">
                 <a:latin typeface="Times New Roman"/>
               </a:rPr>
@@ -360,7 +360,7 @@
         <p:spPr>
           <a:xfrm>
             <a:off x="685800" y="1143000"/>
-            <a:ext cx="5485320" cy="3085200"/>
+            <a:ext cx="5484960" cy="3084840"/>
           </a:xfrm>
           <a:prstGeom prst="rect">
             <a:avLst/>
@@ -383,7 +383,7 @@
         <p:spPr>
           <a:xfrm>
             <a:off x="685800" y="4400640"/>
-            <a:ext cx="5485320" cy="3599280"/>
+            <a:ext cx="5484960" cy="3598920"/>
           </a:xfrm>
           <a:prstGeom prst="rect">
             <a:avLst/>
@@ -417,7 +417,7 @@
         <p:spPr>
           <a:xfrm>
             <a:off x="3884760" y="8685360"/>
-            <a:ext cx="2970720" cy="457560"/>
+            <a:ext cx="2970360" cy="457200"/>
           </a:xfrm>
           <a:prstGeom prst="rect">
             <a:avLst/>
@@ -449,7 +449,7 @@
               </a:lnSpc>
               <a:buNone/>
             </a:pPr>
-            <a:fld id="{A89F1729-7E23-4D15-9DC2-E0204A522688}" type="slidenum">
+            <a:fld id="{0F249DD9-04D3-49AF-9156-F9638A3BB4CC}" type="slidenum">
               <a:rPr b="0" lang="en-US" sz="1200" spc="-1" strike="noStrike">
                 <a:latin typeface="Times New Roman"/>
               </a:rPr>
@@ -496,7 +496,7 @@
         <p:spPr>
           <a:xfrm>
             <a:off x="685800" y="1143000"/>
-            <a:ext cx="5485320" cy="3085200"/>
+            <a:ext cx="5484960" cy="3084840"/>
           </a:xfrm>
           <a:prstGeom prst="rect">
             <a:avLst/>
@@ -519,7 +519,7 @@
         <p:spPr>
           <a:xfrm>
             <a:off x="685800" y="4400640"/>
-            <a:ext cx="5485320" cy="3599280"/>
+            <a:ext cx="5484960" cy="3598920"/>
           </a:xfrm>
           <a:prstGeom prst="rect">
             <a:avLst/>
@@ -553,7 +553,7 @@
         <p:spPr>
           <a:xfrm>
             <a:off x="3884760" y="8685360"/>
-            <a:ext cx="2970720" cy="457560"/>
+            <a:ext cx="2970360" cy="457200"/>
           </a:xfrm>
           <a:prstGeom prst="rect">
             <a:avLst/>
@@ -585,7 +585,7 @@
               </a:lnSpc>
               <a:buNone/>
             </a:pPr>
-            <a:fld id="{4D74A47C-6719-4EDF-AA33-6E3FD0314EBC}" type="slidenum">
+            <a:fld id="{FE8CDD32-BC0A-498E-AE72-EDB50D7CD85E}" type="slidenum">
               <a:rPr b="0" lang="en-US" sz="1200" spc="-1" strike="noStrike">
                 <a:latin typeface="Times New Roman"/>
               </a:rPr>
@@ -632,7 +632,7 @@
         <p:spPr>
           <a:xfrm>
             <a:off x="685800" y="1143000"/>
-            <a:ext cx="5485320" cy="3085200"/>
+            <a:ext cx="5484960" cy="3084840"/>
           </a:xfrm>
           <a:prstGeom prst="rect">
             <a:avLst/>
@@ -655,7 +655,7 @@
         <p:spPr>
           <a:xfrm>
             <a:off x="685800" y="4400640"/>
-            <a:ext cx="5485320" cy="3599280"/>
+            <a:ext cx="5484960" cy="3598920"/>
           </a:xfrm>
           <a:prstGeom prst="rect">
             <a:avLst/>
@@ -689,7 +689,7 @@
         <p:spPr>
           <a:xfrm>
             <a:off x="3884760" y="8685360"/>
-            <a:ext cx="2970720" cy="457560"/>
+            <a:ext cx="2970360" cy="457200"/>
           </a:xfrm>
           <a:prstGeom prst="rect">
             <a:avLst/>
@@ -721,7 +721,7 @@
               </a:lnSpc>
               <a:buNone/>
             </a:pPr>
-            <a:fld id="{524F59DD-F28E-40A5-8582-379CC6DC1860}" type="slidenum">
+            <a:fld id="{F170834E-2CBD-4D1D-BF3F-8160001F531B}" type="slidenum">
               <a:rPr b="0" lang="en-US" sz="1200" spc="-1" strike="noStrike">
                 <a:latin typeface="Times New Roman"/>
               </a:rPr>
@@ -768,7 +768,7 @@
         <p:spPr>
           <a:xfrm>
             <a:off x="685800" y="1143000"/>
-            <a:ext cx="5485320" cy="3085200"/>
+            <a:ext cx="5484960" cy="3084840"/>
           </a:xfrm>
           <a:prstGeom prst="rect">
             <a:avLst/>
@@ -791,7 +791,7 @@
         <p:spPr>
           <a:xfrm>
             <a:off x="685800" y="4400640"/>
-            <a:ext cx="5485320" cy="3599280"/>
+            <a:ext cx="5484960" cy="3598920"/>
           </a:xfrm>
           <a:prstGeom prst="rect">
             <a:avLst/>
@@ -825,7 +825,7 @@
         <p:spPr>
           <a:xfrm>
             <a:off x="3884760" y="8685360"/>
-            <a:ext cx="2970720" cy="457560"/>
+            <a:ext cx="2970360" cy="457200"/>
           </a:xfrm>
           <a:prstGeom prst="rect">
             <a:avLst/>
@@ -857,7 +857,7 @@
               </a:lnSpc>
               <a:buNone/>
             </a:pPr>
-            <a:fld id="{69B80F13-6234-4540-98E2-3A20B67DACB5}" type="slidenum">
+            <a:fld id="{7BE7C717-1176-4DBF-937B-CE728EC0951A}" type="slidenum">
               <a:rPr b="0" lang="en-US" sz="1200" spc="-1" strike="noStrike">
                 <a:latin typeface="Times New Roman"/>
               </a:rPr>
@@ -904,7 +904,7 @@
         <p:spPr>
           <a:xfrm>
             <a:off x="685800" y="1143000"/>
-            <a:ext cx="5485320" cy="3085200"/>
+            <a:ext cx="5484960" cy="3084840"/>
           </a:xfrm>
           <a:prstGeom prst="rect">
             <a:avLst/>
@@ -927,7 +927,7 @@
         <p:spPr>
           <a:xfrm>
             <a:off x="685800" y="4400640"/>
-            <a:ext cx="5485320" cy="3599280"/>
+            <a:ext cx="5484960" cy="3598920"/>
           </a:xfrm>
           <a:prstGeom prst="rect">
             <a:avLst/>
@@ -961,7 +961,7 @@
         <p:spPr>
           <a:xfrm>
             <a:off x="3884760" y="8685360"/>
-            <a:ext cx="2970720" cy="457560"/>
+            <a:ext cx="2970360" cy="457200"/>
           </a:xfrm>
           <a:prstGeom prst="rect">
             <a:avLst/>
@@ -993,7 +993,7 @@
               </a:lnSpc>
               <a:buNone/>
             </a:pPr>
-            <a:fld id="{909D4077-68AE-4B2D-B9EE-EDD54F0AB00C}" type="slidenum">
+            <a:fld id="{C32E9AA7-D62B-4DDD-8FD9-ABC39B7A086D}" type="slidenum">
               <a:rPr b="0" lang="en-US" sz="1200" spc="-1" strike="noStrike">
                 <a:latin typeface="Times New Roman"/>
               </a:rPr>
@@ -1040,7 +1040,7 @@
         <p:spPr>
           <a:xfrm>
             <a:off x="685800" y="1143000"/>
-            <a:ext cx="5485320" cy="3085200"/>
+            <a:ext cx="5484960" cy="3084840"/>
           </a:xfrm>
           <a:prstGeom prst="rect">
             <a:avLst/>
@@ -1063,7 +1063,7 @@
         <p:spPr>
           <a:xfrm>
             <a:off x="685800" y="4400640"/>
-            <a:ext cx="5485320" cy="3599280"/>
+            <a:ext cx="5484960" cy="3598920"/>
           </a:xfrm>
           <a:prstGeom prst="rect">
             <a:avLst/>
@@ -1097,7 +1097,7 @@
         <p:spPr>
           <a:xfrm>
             <a:off x="3884760" y="8685360"/>
-            <a:ext cx="2970720" cy="457560"/>
+            <a:ext cx="2970360" cy="457200"/>
           </a:xfrm>
           <a:prstGeom prst="rect">
             <a:avLst/>
@@ -1129,7 +1129,7 @@
               </a:lnSpc>
               <a:buNone/>
             </a:pPr>
-            <a:fld id="{47A7911D-0114-4BB3-94FA-9E565CD302C7}" type="slidenum">
+            <a:fld id="{51C37B64-01E7-4EB7-9532-6587ECCD3613}" type="slidenum">
               <a:rPr b="0" lang="en-US" sz="1200" spc="-1" strike="noStrike">
                 <a:latin typeface="Times New Roman"/>
               </a:rPr>
@@ -1176,7 +1176,7 @@
         <p:spPr>
           <a:xfrm>
             <a:off x="685800" y="1143000"/>
-            <a:ext cx="5485320" cy="3085200"/>
+            <a:ext cx="5484960" cy="3084840"/>
           </a:xfrm>
           <a:prstGeom prst="rect">
             <a:avLst/>
@@ -1199,7 +1199,7 @@
         <p:spPr>
           <a:xfrm>
             <a:off x="685800" y="4400640"/>
-            <a:ext cx="5485320" cy="3599280"/>
+            <a:ext cx="5484960" cy="3598920"/>
           </a:xfrm>
           <a:prstGeom prst="rect">
             <a:avLst/>
@@ -1233,7 +1233,7 @@
         <p:spPr>
           <a:xfrm>
             <a:off x="3884760" y="8685360"/>
-            <a:ext cx="2970720" cy="457560"/>
+            <a:ext cx="2970360" cy="457200"/>
           </a:xfrm>
           <a:prstGeom prst="rect">
             <a:avLst/>
@@ -1265,7 +1265,7 @@
               </a:lnSpc>
               <a:buNone/>
             </a:pPr>
-            <a:fld id="{AFC1DE17-0338-4339-8E63-D1BC1763AE3E}" type="slidenum">
+            <a:fld id="{2443EFDA-E1B6-42DA-9E60-65FA0DF9D057}" type="slidenum">
               <a:rPr b="0" lang="en-US" sz="1200" spc="-1" strike="noStrike">
                 <a:latin typeface="Times New Roman"/>
               </a:rPr>
@@ -1312,7 +1312,7 @@
         <p:spPr>
           <a:xfrm>
             <a:off x="685800" y="1143000"/>
-            <a:ext cx="5485320" cy="3085200"/>
+            <a:ext cx="5484960" cy="3084840"/>
           </a:xfrm>
           <a:prstGeom prst="rect">
             <a:avLst/>
@@ -1335,7 +1335,7 @@
         <p:spPr>
           <a:xfrm>
             <a:off x="685800" y="4400640"/>
-            <a:ext cx="5485320" cy="3599280"/>
+            <a:ext cx="5484960" cy="3598920"/>
           </a:xfrm>
           <a:prstGeom prst="rect">
             <a:avLst/>
@@ -1369,7 +1369,7 @@
         <p:spPr>
           <a:xfrm>
             <a:off x="3884760" y="8685360"/>
-            <a:ext cx="2970720" cy="457560"/>
+            <a:ext cx="2970360" cy="457200"/>
           </a:xfrm>
           <a:prstGeom prst="rect">
             <a:avLst/>
@@ -1401,7 +1401,7 @@
               </a:lnSpc>
               <a:buNone/>
             </a:pPr>
-            <a:fld id="{01C49605-3FED-4D9C-ACA7-B35A1044E6E6}" type="slidenum">
+            <a:fld id="{F9A7FF5F-0721-4E25-8CA2-73584397BC87}" type="slidenum">
               <a:rPr b="0" lang="en-US" sz="1200" spc="-1" strike="noStrike">
                 <a:latin typeface="Times New Roman"/>
               </a:rPr>
@@ -1448,7 +1448,7 @@
         <p:spPr>
           <a:xfrm>
             <a:off x="685800" y="1143000"/>
-            <a:ext cx="5485320" cy="3085200"/>
+            <a:ext cx="5484960" cy="3084840"/>
           </a:xfrm>
           <a:prstGeom prst="rect">
             <a:avLst/>
@@ -1471,7 +1471,7 @@
         <p:spPr>
           <a:xfrm>
             <a:off x="685800" y="4400640"/>
-            <a:ext cx="5485320" cy="3599280"/>
+            <a:ext cx="5484960" cy="3598920"/>
           </a:xfrm>
           <a:prstGeom prst="rect">
             <a:avLst/>
@@ -1505,7 +1505,7 @@
         <p:spPr>
           <a:xfrm>
             <a:off x="3884760" y="8685360"/>
-            <a:ext cx="2970720" cy="457560"/>
+            <a:ext cx="2970360" cy="457200"/>
           </a:xfrm>
           <a:prstGeom prst="rect">
             <a:avLst/>
@@ -1537,7 +1537,7 @@
               </a:lnSpc>
               <a:buNone/>
             </a:pPr>
-            <a:fld id="{82948815-F6CC-4E8D-9C3C-741BA64D6F9C}" type="slidenum">
+            <a:fld id="{F29D6781-3545-45E6-9D4E-726AA3242CEC}" type="slidenum">
               <a:rPr b="0" lang="en-US" sz="1200" spc="-1" strike="noStrike">
                 <a:latin typeface="Times New Roman"/>
               </a:rPr>
@@ -1584,7 +1584,7 @@
         <p:spPr>
           <a:xfrm>
             <a:off x="685800" y="1143000"/>
-            <a:ext cx="5485320" cy="3085200"/>
+            <a:ext cx="5484960" cy="3084840"/>
           </a:xfrm>
           <a:prstGeom prst="rect">
             <a:avLst/>
@@ -1607,7 +1607,7 @@
         <p:spPr>
           <a:xfrm>
             <a:off x="685800" y="4400640"/>
-            <a:ext cx="5485320" cy="3599280"/>
+            <a:ext cx="5484960" cy="3598920"/>
           </a:xfrm>
           <a:prstGeom prst="rect">
             <a:avLst/>
@@ -1641,7 +1641,7 @@
         <p:spPr>
           <a:xfrm>
             <a:off x="3884760" y="8685360"/>
-            <a:ext cx="2970720" cy="457560"/>
+            <a:ext cx="2970360" cy="457200"/>
           </a:xfrm>
           <a:prstGeom prst="rect">
             <a:avLst/>
@@ -1673,7 +1673,7 @@
               </a:lnSpc>
               <a:buNone/>
             </a:pPr>
-            <a:fld id="{DE4A07FD-2326-4302-9A75-9E41E06C6C9C}" type="slidenum">
+            <a:fld id="{1EBE8B5E-A0A7-45DE-9AB6-1B8370F4D384}" type="slidenum">
               <a:rPr b="0" lang="en-US" sz="1200" spc="-1" strike="noStrike">
                 <a:latin typeface="Times New Roman"/>
               </a:rPr>
@@ -1720,7 +1720,7 @@
         <p:spPr>
           <a:xfrm>
             <a:off x="685800" y="1143000"/>
-            <a:ext cx="5485320" cy="3085200"/>
+            <a:ext cx="5484960" cy="3084840"/>
           </a:xfrm>
           <a:prstGeom prst="rect">
             <a:avLst/>
@@ -1743,7 +1743,7 @@
         <p:spPr>
           <a:xfrm>
             <a:off x="685800" y="4400640"/>
-            <a:ext cx="5485320" cy="3599280"/>
+            <a:ext cx="5484960" cy="3598920"/>
           </a:xfrm>
           <a:prstGeom prst="rect">
             <a:avLst/>
@@ -1777,7 +1777,7 @@
         <p:spPr>
           <a:xfrm>
             <a:off x="3884760" y="8685360"/>
-            <a:ext cx="2970720" cy="457560"/>
+            <a:ext cx="2970360" cy="457200"/>
           </a:xfrm>
           <a:prstGeom prst="rect">
             <a:avLst/>
@@ -1809,7 +1809,7 @@
               </a:lnSpc>
               <a:buNone/>
             </a:pPr>
-            <a:fld id="{60D42350-FE0E-43C4-BE4A-45FAE3D850E2}" type="slidenum">
+            <a:fld id="{08A43EC0-934C-412E-8C78-3DD3B93B6D54}" type="slidenum">
               <a:rPr b="0" lang="en-US" sz="1200" spc="-1" strike="noStrike">
                 <a:latin typeface="Times New Roman"/>
               </a:rPr>
@@ -1856,7 +1856,7 @@
         <p:spPr>
           <a:xfrm>
             <a:off x="685800" y="1143000"/>
-            <a:ext cx="5485320" cy="3085200"/>
+            <a:ext cx="5484960" cy="3084840"/>
           </a:xfrm>
           <a:prstGeom prst="rect">
             <a:avLst/>
@@ -1879,7 +1879,7 @@
         <p:spPr>
           <a:xfrm>
             <a:off x="685800" y="4400640"/>
-            <a:ext cx="5485320" cy="3599280"/>
+            <a:ext cx="5484960" cy="3598920"/>
           </a:xfrm>
           <a:prstGeom prst="rect">
             <a:avLst/>
@@ -1913,7 +1913,7 @@
         <p:spPr>
           <a:xfrm>
             <a:off x="3884760" y="8685360"/>
-            <a:ext cx="2970720" cy="457560"/>
+            <a:ext cx="2970360" cy="457200"/>
           </a:xfrm>
           <a:prstGeom prst="rect">
             <a:avLst/>
@@ -1945,7 +1945,7 @@
               </a:lnSpc>
               <a:buNone/>
             </a:pPr>
-            <a:fld id="{80E089FC-6135-42AD-84A6-3D5A894AF527}" type="slidenum">
+            <a:fld id="{A2E9DB7E-1869-4F56-969D-25CFD737AF72}" type="slidenum">
               <a:rPr b="0" lang="en-US" sz="1200" spc="-1" strike="noStrike">
                 <a:latin typeface="Times New Roman"/>
               </a:rPr>
@@ -1992,7 +1992,7 @@
         <p:spPr>
           <a:xfrm>
             <a:off x="685800" y="1143000"/>
-            <a:ext cx="5485320" cy="3085200"/>
+            <a:ext cx="5484960" cy="3084840"/>
           </a:xfrm>
           <a:prstGeom prst="rect">
             <a:avLst/>
@@ -2015,7 +2015,7 @@
         <p:spPr>
           <a:xfrm>
             <a:off x="685800" y="4400640"/>
-            <a:ext cx="5485320" cy="3599280"/>
+            <a:ext cx="5484960" cy="3598920"/>
           </a:xfrm>
           <a:prstGeom prst="rect">
             <a:avLst/>
@@ -2049,7 +2049,7 @@
         <p:spPr>
           <a:xfrm>
             <a:off x="3884760" y="8685360"/>
-            <a:ext cx="2970720" cy="457560"/>
+            <a:ext cx="2970360" cy="457200"/>
           </a:xfrm>
           <a:prstGeom prst="rect">
             <a:avLst/>
@@ -2081,7 +2081,7 @@
               </a:lnSpc>
               <a:buNone/>
             </a:pPr>
-            <a:fld id="{29636E88-0D1D-487D-99FD-549889DDE361}" type="slidenum">
+            <a:fld id="{9DBFF776-BD76-477C-A5F6-EE95F38307C1}" type="slidenum">
               <a:rPr b="0" lang="en-US" sz="1200" spc="-1" strike="noStrike">
                 <a:latin typeface="Times New Roman"/>
               </a:rPr>
@@ -2128,7 +2128,7 @@
         <p:spPr>
           <a:xfrm>
             <a:off x="685800" y="1143000"/>
-            <a:ext cx="5485320" cy="3085200"/>
+            <a:ext cx="5484960" cy="3084840"/>
           </a:xfrm>
           <a:prstGeom prst="rect">
             <a:avLst/>
@@ -2151,7 +2151,7 @@
         <p:spPr>
           <a:xfrm>
             <a:off x="685800" y="4400640"/>
-            <a:ext cx="5485320" cy="3599280"/>
+            <a:ext cx="5484960" cy="3598920"/>
           </a:xfrm>
           <a:prstGeom prst="rect">
             <a:avLst/>
@@ -2185,7 +2185,7 @@
         <p:spPr>
           <a:xfrm>
             <a:off x="3884760" y="8685360"/>
-            <a:ext cx="2970720" cy="457560"/>
+            <a:ext cx="2970360" cy="457200"/>
           </a:xfrm>
           <a:prstGeom prst="rect">
             <a:avLst/>
@@ -2217,7 +2217,7 @@
               </a:lnSpc>
               <a:buNone/>
             </a:pPr>
-            <a:fld id="{CB7B5D7A-D472-48D0-BCE0-AC4B5D3F4264}" type="slidenum">
+            <a:fld id="{AF49C7A3-C3F8-4BC3-B47E-34AEFC5816E7}" type="slidenum">
               <a:rPr b="0" lang="en-US" sz="1200" spc="-1" strike="noStrike">
                 <a:latin typeface="Times New Roman"/>
               </a:rPr>
@@ -2264,7 +2264,7 @@
         <p:spPr>
           <a:xfrm>
             <a:off x="685800" y="1143000"/>
-            <a:ext cx="5485320" cy="3085200"/>
+            <a:ext cx="5484960" cy="3084840"/>
           </a:xfrm>
           <a:prstGeom prst="rect">
             <a:avLst/>
@@ -2287,7 +2287,7 @@
         <p:spPr>
           <a:xfrm>
             <a:off x="685800" y="4400640"/>
-            <a:ext cx="5485320" cy="3599280"/>
+            <a:ext cx="5484960" cy="3598920"/>
           </a:xfrm>
           <a:prstGeom prst="rect">
             <a:avLst/>
@@ -2321,7 +2321,7 @@
         <p:spPr>
           <a:xfrm>
             <a:off x="3884760" y="8685360"/>
-            <a:ext cx="2970720" cy="457560"/>
+            <a:ext cx="2970360" cy="457200"/>
           </a:xfrm>
           <a:prstGeom prst="rect">
             <a:avLst/>
@@ -2353,7 +2353,7 @@
               </a:lnSpc>
               <a:buNone/>
             </a:pPr>
-            <a:fld id="{120C2021-1030-4988-87F8-77A8B31B48BC}" type="slidenum">
+            <a:fld id="{A146B983-5825-4158-B44E-96F9EEF207F5}" type="slidenum">
               <a:rPr b="0" lang="en-US" sz="1200" spc="-1" strike="noStrike">
                 <a:latin typeface="Times New Roman"/>
               </a:rPr>
@@ -2400,7 +2400,7 @@
         <p:spPr>
           <a:xfrm>
             <a:off x="685800" y="1143000"/>
-            <a:ext cx="5485320" cy="3085200"/>
+            <a:ext cx="5484960" cy="3084840"/>
           </a:xfrm>
           <a:prstGeom prst="rect">
             <a:avLst/>
@@ -2423,7 +2423,7 @@
         <p:spPr>
           <a:xfrm>
             <a:off x="685800" y="4400640"/>
-            <a:ext cx="5485320" cy="3599280"/>
+            <a:ext cx="5484960" cy="3598920"/>
           </a:xfrm>
           <a:prstGeom prst="rect">
             <a:avLst/>
@@ -2457,7 +2457,7 @@
         <p:spPr>
           <a:xfrm>
             <a:off x="3884760" y="8685360"/>
-            <a:ext cx="2970720" cy="457560"/>
+            <a:ext cx="2970360" cy="457200"/>
           </a:xfrm>
           <a:prstGeom prst="rect">
             <a:avLst/>
@@ -2489,7 +2489,7 @@
               </a:lnSpc>
               <a:buNone/>
             </a:pPr>
-            <a:fld id="{1E63A79E-C749-4AE8-8B5B-A8FCD6C57288}" type="slidenum">
+            <a:fld id="{FBA4BE3D-402E-4E2E-82AC-700F40EA960F}" type="slidenum">
               <a:rPr b="0" lang="en-US" sz="1200" spc="-1" strike="noStrike">
                 <a:latin typeface="Times New Roman"/>
               </a:rPr>
@@ -2536,7 +2536,7 @@
         <p:spPr>
           <a:xfrm>
             <a:off x="685800" y="1143000"/>
-            <a:ext cx="5485320" cy="3085200"/>
+            <a:ext cx="5484960" cy="3084840"/>
           </a:xfrm>
           <a:prstGeom prst="rect">
             <a:avLst/>
@@ -2559,7 +2559,7 @@
         <p:spPr>
           <a:xfrm>
             <a:off x="685800" y="4400640"/>
-            <a:ext cx="5485320" cy="3599280"/>
+            <a:ext cx="5484960" cy="3598920"/>
           </a:xfrm>
           <a:prstGeom prst="rect">
             <a:avLst/>
@@ -2593,7 +2593,7 @@
         <p:spPr>
           <a:xfrm>
             <a:off x="3884760" y="8685360"/>
-            <a:ext cx="2970720" cy="457560"/>
+            <a:ext cx="2970360" cy="457200"/>
           </a:xfrm>
           <a:prstGeom prst="rect">
             <a:avLst/>
@@ -2625,7 +2625,7 @@
               </a:lnSpc>
               <a:buNone/>
             </a:pPr>
-            <a:fld id="{D93D1799-1BD7-49BE-90CF-23B0F600DAE2}" type="slidenum">
+            <a:fld id="{689C2BB8-BCBA-4E10-BB01-39CE83F73952}" type="slidenum">
               <a:rPr b="0" lang="en-US" sz="1200" spc="-1" strike="noStrike">
                 <a:latin typeface="Times New Roman"/>
               </a:rPr>
@@ -2672,7 +2672,7 @@
         <p:spPr>
           <a:xfrm>
             <a:off x="685800" y="1143000"/>
-            <a:ext cx="5485320" cy="3085200"/>
+            <a:ext cx="5484960" cy="3084840"/>
           </a:xfrm>
           <a:prstGeom prst="rect">
             <a:avLst/>
@@ -2695,7 +2695,7 @@
         <p:spPr>
           <a:xfrm>
             <a:off x="685800" y="4400640"/>
-            <a:ext cx="5485320" cy="3599280"/>
+            <a:ext cx="5484960" cy="3598920"/>
           </a:xfrm>
           <a:prstGeom prst="rect">
             <a:avLst/>
@@ -2729,7 +2729,7 @@
         <p:spPr>
           <a:xfrm>
             <a:off x="3884760" y="8685360"/>
-            <a:ext cx="2970720" cy="457560"/>
+            <a:ext cx="2970360" cy="457200"/>
           </a:xfrm>
           <a:prstGeom prst="rect">
             <a:avLst/>
@@ -2761,7 +2761,7 @@
               </a:lnSpc>
               <a:buNone/>
             </a:pPr>
-            <a:fld id="{02EF6FD3-C1B7-4026-B3AC-E43584CB0904}" type="slidenum">
+            <a:fld id="{9DF01770-A7FA-4D4D-BD59-990079766E58}" type="slidenum">
               <a:rPr b="0" lang="en-US" sz="1200" spc="-1" strike="noStrike">
                 <a:latin typeface="Times New Roman"/>
               </a:rPr>
@@ -2808,7 +2808,7 @@
         <p:spPr>
           <a:xfrm>
             <a:off x="685800" y="1143000"/>
-            <a:ext cx="5485320" cy="3085200"/>
+            <a:ext cx="5484960" cy="3084840"/>
           </a:xfrm>
           <a:prstGeom prst="rect">
             <a:avLst/>
@@ -2831,7 +2831,7 @@
         <p:spPr>
           <a:xfrm>
             <a:off x="685800" y="4400640"/>
-            <a:ext cx="5485320" cy="3599280"/>
+            <a:ext cx="5484960" cy="3598920"/>
           </a:xfrm>
           <a:prstGeom prst="rect">
             <a:avLst/>
@@ -2865,7 +2865,7 @@
         <p:spPr>
           <a:xfrm>
             <a:off x="3884760" y="8685360"/>
-            <a:ext cx="2970720" cy="457560"/>
+            <a:ext cx="2970360" cy="457200"/>
           </a:xfrm>
           <a:prstGeom prst="rect">
             <a:avLst/>
@@ -2897,7 +2897,7 @@
               </a:lnSpc>
               <a:buNone/>
             </a:pPr>
-            <a:fld id="{CF652E16-76D9-4576-9F05-09F007C673F1}" type="slidenum">
+            <a:fld id="{E9DEA413-EBBF-4054-9F0C-D094C50E50EC}" type="slidenum">
               <a:rPr b="0" lang="en-US" sz="1200" spc="-1" strike="noStrike">
                 <a:latin typeface="Times New Roman"/>
               </a:rPr>
@@ -2944,7 +2944,7 @@
         <p:spPr>
           <a:xfrm>
             <a:off x="685800" y="1143000"/>
-            <a:ext cx="5485320" cy="3085200"/>
+            <a:ext cx="5484960" cy="3084840"/>
           </a:xfrm>
           <a:prstGeom prst="rect">
             <a:avLst/>
@@ -2967,7 +2967,7 @@
         <p:spPr>
           <a:xfrm>
             <a:off x="685800" y="4400640"/>
-            <a:ext cx="5485320" cy="3599280"/>
+            <a:ext cx="5484960" cy="3598920"/>
           </a:xfrm>
           <a:prstGeom prst="rect">
             <a:avLst/>
@@ -3001,7 +3001,7 @@
         <p:spPr>
           <a:xfrm>
             <a:off x="3884760" y="8685360"/>
-            <a:ext cx="2970720" cy="457560"/>
+            <a:ext cx="2970360" cy="457200"/>
           </a:xfrm>
           <a:prstGeom prst="rect">
             <a:avLst/>
@@ -3033,7 +3033,7 @@
               </a:lnSpc>
               <a:buNone/>
             </a:pPr>
-            <a:fld id="{D682E927-06A7-4421-B2F3-7EBAC31AE1A0}" type="slidenum">
+            <a:fld id="{C83D4984-F26B-43E9-AAC5-9F6BA3B705B0}" type="slidenum">
               <a:rPr b="0" lang="en-US" sz="1200" spc="-1" strike="noStrike">
                 <a:latin typeface="Times New Roman"/>
               </a:rPr>
@@ -3080,7 +3080,7 @@
         <p:spPr>
           <a:xfrm>
             <a:off x="685800" y="1143000"/>
-            <a:ext cx="5485320" cy="3085200"/>
+            <a:ext cx="5484960" cy="3084840"/>
           </a:xfrm>
           <a:prstGeom prst="rect">
             <a:avLst/>
@@ -3103,7 +3103,7 @@
         <p:spPr>
           <a:xfrm>
             <a:off x="685800" y="4400640"/>
-            <a:ext cx="5485320" cy="3599280"/>
+            <a:ext cx="5484960" cy="3598920"/>
           </a:xfrm>
           <a:prstGeom prst="rect">
             <a:avLst/>
@@ -3137,7 +3137,7 @@
         <p:spPr>
           <a:xfrm>
             <a:off x="3884760" y="8685360"/>
-            <a:ext cx="2970720" cy="457560"/>
+            <a:ext cx="2970360" cy="457200"/>
           </a:xfrm>
           <a:prstGeom prst="rect">
             <a:avLst/>
@@ -3169,7 +3169,7 @@
               </a:lnSpc>
               <a:buNone/>
             </a:pPr>
-            <a:fld id="{8B87F8C4-7A33-4D32-B933-FB6388F0CA08}" type="slidenum">
+            <a:fld id="{D16A26F5-0FC3-4D63-90AC-AE08FA23385A}" type="slidenum">
               <a:rPr b="0" lang="en-US" sz="1200" spc="-1" strike="noStrike">
                 <a:latin typeface="Times New Roman"/>
               </a:rPr>
@@ -5013,7 +5013,7 @@
         <p:spPr>
           <a:xfrm>
             <a:off x="5638680" y="2266920"/>
-            <a:ext cx="913320" cy="18000"/>
+            <a:ext cx="912960" cy="17640"/>
           </a:xfrm>
           <a:custGeom>
             <a:avLst/>
@@ -5064,7 +5064,7 @@
         <p:spPr>
           <a:xfrm>
             <a:off x="3633840" y="2514600"/>
-            <a:ext cx="4923360" cy="913320"/>
+            <a:ext cx="4923000" cy="912960"/>
           </a:xfrm>
           <a:prstGeom prst="rect">
             <a:avLst/>
@@ -5116,7 +5116,7 @@
         <p:spPr>
           <a:xfrm>
             <a:off x="5638680" y="3657600"/>
-            <a:ext cx="913320" cy="18000"/>
+            <a:ext cx="912960" cy="17640"/>
           </a:xfrm>
           <a:custGeom>
             <a:avLst/>
@@ -5167,7 +5167,7 @@
         <p:spPr>
           <a:xfrm>
             <a:off x="3545640" y="4286160"/>
-            <a:ext cx="5094720" cy="303840"/>
+            <a:ext cx="5094360" cy="303480"/>
           </a:xfrm>
           <a:prstGeom prst="rect">
             <a:avLst/>
@@ -5195,7 +5195,7 @@
               <a:buNone/>
             </a:pPr>
             <a:r>
-              <a:rPr b="0" lang="en-US" sz="1800" spc="38" strike="noStrike">
+              <a:rPr b="0" lang="en-US" sz="1800" spc="35" strike="noStrike">
                 <a:solidFill>
                   <a:srgbClr val="636e72"/>
                 </a:solidFill>
@@ -5256,7 +5256,7 @@
         <p:spPr>
           <a:xfrm>
             <a:off x="380880" y="380880"/>
-            <a:ext cx="11505240" cy="227520"/>
+            <a:ext cx="11504880" cy="227160"/>
           </a:xfrm>
           <a:prstGeom prst="rect">
             <a:avLst/>
@@ -5284,7 +5284,7 @@
               <a:buNone/>
             </a:pPr>
             <a:r>
-              <a:rPr b="1" lang="en-US" sz="1200" spc="52" strike="noStrike">
+              <a:rPr b="1" lang="en-US" sz="1200" spc="49" strike="noStrike">
                 <a:solidFill>
                   <a:srgbClr val="0984e3"/>
                 </a:solidFill>
@@ -5308,7 +5308,7 @@
         <p:spPr>
           <a:xfrm>
             <a:off x="380880" y="685800"/>
-            <a:ext cx="11657520" cy="456120"/>
+            <a:ext cx="11657160" cy="455760"/>
           </a:xfrm>
           <a:prstGeom prst="rect">
             <a:avLst/>
@@ -5360,7 +5360,7 @@
         <p:spPr>
           <a:xfrm>
             <a:off x="380880" y="1419120"/>
-            <a:ext cx="5496120" cy="827640"/>
+            <a:ext cx="5495760" cy="827280"/>
           </a:xfrm>
           <a:prstGeom prst="rect">
             <a:avLst/>
@@ -5412,7 +5412,7 @@
         <p:spPr>
           <a:xfrm>
             <a:off x="380880" y="2452680"/>
-            <a:ext cx="5647320" cy="837000"/>
+            <a:ext cx="5646960" cy="836640"/>
           </a:xfrm>
           <a:prstGeom prst="rect">
             <a:avLst/>
@@ -5464,7 +5464,7 @@
         <p:spPr>
           <a:xfrm>
             <a:off x="380880" y="3867120"/>
-            <a:ext cx="5561640" cy="2018160"/>
+            <a:ext cx="5561280" cy="2017800"/>
           </a:xfrm>
           <a:custGeom>
             <a:avLst/>
@@ -5515,7 +5515,7 @@
         <p:spPr>
           <a:xfrm>
             <a:off x="609480" y="4095720"/>
-            <a:ext cx="5199480" cy="265680"/>
+            <a:ext cx="5199120" cy="265320"/>
           </a:xfrm>
           <a:prstGeom prst="rect">
             <a:avLst/>
@@ -5567,7 +5567,7 @@
         <p:spPr>
           <a:xfrm>
             <a:off x="609480" y="4476600"/>
-            <a:ext cx="5180400" cy="246600"/>
+            <a:ext cx="5180040" cy="246240"/>
           </a:xfrm>
           <a:prstGeom prst="rect">
             <a:avLst/>
@@ -5659,7 +5659,7 @@
         <p:spPr>
           <a:xfrm>
             <a:off x="609480" y="4838760"/>
-            <a:ext cx="5104440" cy="456120"/>
+            <a:ext cx="5104080" cy="455760"/>
           </a:xfrm>
           <a:custGeom>
             <a:avLst/>
@@ -5710,7 +5710,7 @@
         <p:spPr>
           <a:xfrm>
             <a:off x="609480" y="4838760"/>
-            <a:ext cx="5180400" cy="456120"/>
+            <a:ext cx="5180040" cy="455760"/>
           </a:xfrm>
           <a:prstGeom prst="rect">
             <a:avLst/>
@@ -5762,7 +5762,7 @@
         <p:spPr>
           <a:xfrm>
             <a:off x="609480" y="5410080"/>
-            <a:ext cx="5180400" cy="246600"/>
+            <a:ext cx="5180040" cy="246240"/>
           </a:xfrm>
           <a:prstGeom prst="rect">
             <a:avLst/>
@@ -5834,7 +5834,7 @@
         <p:spPr>
           <a:xfrm>
             <a:off x="6253200" y="1376280"/>
-            <a:ext cx="5551920" cy="3208680"/>
+            <a:ext cx="5551560" cy="3208320"/>
           </a:xfrm>
           <a:custGeom>
             <a:avLst/>
@@ -5888,7 +5888,7 @@
         <p:spPr>
           <a:xfrm>
             <a:off x="6486480" y="1609560"/>
-            <a:ext cx="5180400" cy="265680"/>
+            <a:ext cx="5180040" cy="265320"/>
           </a:xfrm>
           <a:prstGeom prst="rect">
             <a:avLst/>
@@ -5940,7 +5940,7 @@
         <p:spPr>
           <a:xfrm>
             <a:off x="6486480" y="2028960"/>
-            <a:ext cx="303840" cy="303840"/>
+            <a:ext cx="303480" cy="303480"/>
           </a:xfrm>
           <a:custGeom>
             <a:avLst/>
@@ -5991,7 +5991,7 @@
         <p:spPr>
           <a:xfrm>
             <a:off x="6453360" y="2028960"/>
-            <a:ext cx="370440" cy="303840"/>
+            <a:ext cx="370080" cy="303480"/>
           </a:xfrm>
           <a:prstGeom prst="rect">
             <a:avLst/>
@@ -6043,7 +6043,7 @@
         <p:spPr>
           <a:xfrm>
             <a:off x="6905520" y="2028960"/>
-            <a:ext cx="3066120" cy="227520"/>
+            <a:ext cx="3065760" cy="227160"/>
           </a:xfrm>
           <a:prstGeom prst="rect">
             <a:avLst/>
@@ -6095,7 +6095,7 @@
         <p:spPr>
           <a:xfrm>
             <a:off x="6905520" y="2295360"/>
-            <a:ext cx="3066120" cy="227520"/>
+            <a:ext cx="3065760" cy="227160"/>
           </a:xfrm>
           <a:prstGeom prst="rect">
             <a:avLst/>
@@ -6147,7 +6147,7 @@
         <p:spPr>
           <a:xfrm>
             <a:off x="6486480" y="2638440"/>
-            <a:ext cx="303840" cy="303840"/>
+            <a:ext cx="303480" cy="303480"/>
           </a:xfrm>
           <a:custGeom>
             <a:avLst/>
@@ -6198,7 +6198,7 @@
         <p:spPr>
           <a:xfrm>
             <a:off x="6453360" y="2638440"/>
-            <a:ext cx="370440" cy="303840"/>
+            <a:ext cx="370080" cy="303480"/>
           </a:xfrm>
           <a:prstGeom prst="rect">
             <a:avLst/>
@@ -6250,7 +6250,7 @@
         <p:spPr>
           <a:xfrm>
             <a:off x="6905520" y="2638440"/>
-            <a:ext cx="3665880" cy="227520"/>
+            <a:ext cx="3665520" cy="227160"/>
           </a:xfrm>
           <a:prstGeom prst="rect">
             <a:avLst/>
@@ -6302,7 +6302,7 @@
         <p:spPr>
           <a:xfrm>
             <a:off x="6905520" y="2905200"/>
-            <a:ext cx="3665880" cy="227520"/>
+            <a:ext cx="3665520" cy="227160"/>
           </a:xfrm>
           <a:prstGeom prst="rect">
             <a:avLst/>
@@ -6354,7 +6354,7 @@
         <p:spPr>
           <a:xfrm>
             <a:off x="6486480" y="3247920"/>
-            <a:ext cx="303840" cy="303840"/>
+            <a:ext cx="303480" cy="303480"/>
           </a:xfrm>
           <a:custGeom>
             <a:avLst/>
@@ -6405,7 +6405,7 @@
         <p:spPr>
           <a:xfrm>
             <a:off x="6453360" y="3247920"/>
-            <a:ext cx="370440" cy="303840"/>
+            <a:ext cx="370080" cy="303480"/>
           </a:xfrm>
           <a:prstGeom prst="rect">
             <a:avLst/>
@@ -6457,7 +6457,7 @@
         <p:spPr>
           <a:xfrm>
             <a:off x="6905520" y="3247920"/>
-            <a:ext cx="3285000" cy="227520"/>
+            <a:ext cx="3284640" cy="227160"/>
           </a:xfrm>
           <a:prstGeom prst="rect">
             <a:avLst/>
@@ -6509,7 +6509,7 @@
         <p:spPr>
           <a:xfrm>
             <a:off x="6905520" y="3514680"/>
-            <a:ext cx="3285000" cy="227520"/>
+            <a:ext cx="3284640" cy="227160"/>
           </a:xfrm>
           <a:prstGeom prst="rect">
             <a:avLst/>
@@ -6561,7 +6561,7 @@
         <p:spPr>
           <a:xfrm>
             <a:off x="6486480" y="3857760"/>
-            <a:ext cx="303840" cy="303840"/>
+            <a:ext cx="303480" cy="303480"/>
           </a:xfrm>
           <a:custGeom>
             <a:avLst/>
@@ -6612,7 +6612,7 @@
         <p:spPr>
           <a:xfrm>
             <a:off x="6453360" y="3857760"/>
-            <a:ext cx="370440" cy="303840"/>
+            <a:ext cx="370080" cy="303480"/>
           </a:xfrm>
           <a:prstGeom prst="rect">
             <a:avLst/>
@@ -6664,7 +6664,7 @@
         <p:spPr>
           <a:xfrm>
             <a:off x="6905520" y="3857760"/>
-            <a:ext cx="4132800" cy="227520"/>
+            <a:ext cx="4132440" cy="227160"/>
           </a:xfrm>
           <a:prstGeom prst="rect">
             <a:avLst/>
@@ -6716,7 +6716,7 @@
         <p:spPr>
           <a:xfrm>
             <a:off x="6905520" y="4124160"/>
-            <a:ext cx="4132800" cy="227520"/>
+            <a:ext cx="4132440" cy="227160"/>
           </a:xfrm>
           <a:prstGeom prst="rect">
             <a:avLst/>
@@ -6768,7 +6768,7 @@
         <p:spPr>
           <a:xfrm>
             <a:off x="6267600" y="4743360"/>
-            <a:ext cx="5542560" cy="1141920"/>
+            <a:ext cx="5542200" cy="1141560"/>
           </a:xfrm>
           <a:custGeom>
             <a:avLst/>
@@ -6819,7 +6819,7 @@
         <p:spPr>
           <a:xfrm>
             <a:off x="6267600" y="4743360"/>
-            <a:ext cx="37080" cy="1141920"/>
+            <a:ext cx="36720" cy="1141560"/>
           </a:xfrm>
           <a:custGeom>
             <a:avLst/>
@@ -6870,7 +6870,7 @@
         <p:spPr>
           <a:xfrm>
             <a:off x="6477120" y="4933800"/>
-            <a:ext cx="5218560" cy="494280"/>
+            <a:ext cx="5218200" cy="493920"/>
           </a:xfrm>
           <a:prstGeom prst="rect">
             <a:avLst/>
@@ -6922,7 +6922,7 @@
         <p:spPr>
           <a:xfrm>
             <a:off x="6477120" y="5505480"/>
-            <a:ext cx="5209200" cy="189360"/>
+            <a:ext cx="5208840" cy="189000"/>
           </a:xfrm>
           <a:prstGeom prst="rect">
             <a:avLst/>
@@ -7021,7 +7021,7 @@
         <p:spPr>
           <a:xfrm>
             <a:off x="379440" y="379440"/>
-            <a:ext cx="11507760" cy="226800"/>
+            <a:ext cx="11507400" cy="226440"/>
           </a:xfrm>
           <a:prstGeom prst="rect">
             <a:avLst/>
@@ -7049,7 +7049,7 @@
               <a:buNone/>
             </a:pPr>
             <a:r>
-              <a:rPr b="1" lang="en-US" sz="1200" spc="52" strike="noStrike">
+              <a:rPr b="1" lang="en-US" sz="1200" spc="49" strike="noStrike">
                 <a:solidFill>
                   <a:srgbClr val="0984e3"/>
                 </a:solidFill>
@@ -7073,7 +7073,7 @@
         <p:spPr>
           <a:xfrm>
             <a:off x="379440" y="683280"/>
-            <a:ext cx="11659680" cy="454320"/>
+            <a:ext cx="11659320" cy="453960"/>
           </a:xfrm>
           <a:prstGeom prst="rect">
             <a:avLst/>
@@ -7125,7 +7125,7 @@
         <p:spPr>
           <a:xfrm>
             <a:off x="379440" y="1366200"/>
-            <a:ext cx="5682240" cy="302400"/>
+            <a:ext cx="5681880" cy="302040"/>
           </a:xfrm>
           <a:prstGeom prst="rect">
             <a:avLst/>
@@ -7177,7 +7177,7 @@
         <p:spPr>
           <a:xfrm>
             <a:off x="379440" y="1826280"/>
-            <a:ext cx="5096160" cy="466200"/>
+            <a:ext cx="5095800" cy="465840"/>
           </a:xfrm>
           <a:prstGeom prst="rect">
             <a:avLst/>
@@ -7229,7 +7229,7 @@
         <p:spPr>
           <a:xfrm>
             <a:off x="379440" y="2452680"/>
-            <a:ext cx="5644080" cy="739080"/>
+            <a:ext cx="5643720" cy="738720"/>
           </a:xfrm>
           <a:prstGeom prst="rect">
             <a:avLst/>
@@ -7281,7 +7281,7 @@
         <p:spPr>
           <a:xfrm>
             <a:off x="398520" y="3306600"/>
-            <a:ext cx="5549400" cy="757800"/>
+            <a:ext cx="5549040" cy="757440"/>
           </a:xfrm>
           <a:custGeom>
             <a:avLst/>
@@ -7332,7 +7332,7 @@
         <p:spPr>
           <a:xfrm>
             <a:off x="398520" y="3306600"/>
-            <a:ext cx="36720" cy="757800"/>
+            <a:ext cx="36360" cy="757440"/>
           </a:xfrm>
           <a:custGeom>
             <a:avLst/>
@@ -7383,7 +7383,7 @@
         <p:spPr>
           <a:xfrm>
             <a:off x="569160" y="3458520"/>
-            <a:ext cx="5302800" cy="454320"/>
+            <a:ext cx="5302440" cy="453960"/>
           </a:xfrm>
           <a:prstGeom prst="rect">
             <a:avLst/>
@@ -7476,7 +7476,7 @@
         <p:spPr>
           <a:xfrm>
             <a:off x="379440" y="4217400"/>
-            <a:ext cx="5682240" cy="302400"/>
+            <a:ext cx="5681880" cy="302040"/>
           </a:xfrm>
           <a:prstGeom prst="rect">
             <a:avLst/>
@@ -7528,7 +7528,7 @@
         <p:spPr>
           <a:xfrm>
             <a:off x="379440" y="4635000"/>
-            <a:ext cx="5644080" cy="739080"/>
+            <a:ext cx="5643720" cy="738720"/>
           </a:xfrm>
           <a:prstGeom prst="rect">
             <a:avLst/>
@@ -7580,7 +7580,7 @@
         <p:spPr>
           <a:xfrm>
             <a:off x="6249240" y="1366200"/>
-            <a:ext cx="5682240" cy="302400"/>
+            <a:ext cx="5681880" cy="302040"/>
           </a:xfrm>
           <a:prstGeom prst="rect">
             <a:avLst/>
@@ -7632,7 +7632,7 @@
         <p:spPr>
           <a:xfrm>
             <a:off x="6249240" y="1826280"/>
-            <a:ext cx="5249520" cy="466200"/>
+            <a:ext cx="5249160" cy="465840"/>
           </a:xfrm>
           <a:prstGeom prst="rect">
             <a:avLst/>
@@ -7684,7 +7684,7 @@
         <p:spPr>
           <a:xfrm>
             <a:off x="6249240" y="2452680"/>
-            <a:ext cx="5644080" cy="739080"/>
+            <a:ext cx="5643720" cy="738720"/>
           </a:xfrm>
           <a:prstGeom prst="rect">
             <a:avLst/>
@@ -7736,7 +7736,7 @@
         <p:spPr>
           <a:xfrm>
             <a:off x="6249240" y="3344400"/>
-            <a:ext cx="5568480" cy="2181240"/>
+            <a:ext cx="5568120" cy="2180880"/>
           </a:xfrm>
           <a:custGeom>
             <a:avLst/>
@@ -7787,7 +7787,7 @@
         <p:spPr>
           <a:xfrm>
             <a:off x="6438960" y="3534120"/>
-            <a:ext cx="5283720" cy="264600"/>
+            <a:ext cx="5283360" cy="264240"/>
           </a:xfrm>
           <a:prstGeom prst="rect">
             <a:avLst/>
@@ -7839,7 +7839,7 @@
         <p:spPr>
           <a:xfrm>
             <a:off x="6438960" y="3913920"/>
-            <a:ext cx="5264640" cy="245520"/>
+            <a:ext cx="5264280" cy="245160"/>
           </a:xfrm>
           <a:prstGeom prst="rect">
             <a:avLst/>
@@ -7891,7 +7891,7 @@
         <p:spPr>
           <a:xfrm>
             <a:off x="6438960" y="4274280"/>
-            <a:ext cx="5188680" cy="454320"/>
+            <a:ext cx="5188320" cy="453960"/>
           </a:xfrm>
           <a:custGeom>
             <a:avLst/>
@@ -7942,24 +7942,24 @@
         <p:spPr>
           <a:xfrm>
             <a:off x="6438960" y="4274280"/>
-            <a:ext cx="5264640" cy="454320"/>
-          </a:xfrm>
-          <a:prstGeom prst="rect">
-            <a:avLst/>
-          </a:prstGeom>
-          <a:noFill/>
-          <a:ln w="0">
-            <a:noFill/>
-          </a:ln>
-        </p:spPr>
-        <p:style>
-          <a:lnRef idx="0"/>
-          <a:fillRef idx="0"/>
-          <a:effectRef idx="0"/>
-          <a:fontRef idx="minor"/>
-        </p:style>
-        <p:txBody>
-          <a:bodyPr lIns="113760" rIns="113760" tIns="227520" bIns="227520" anchor="ctr">
+            <a:ext cx="5264280" cy="453960"/>
+          </a:xfrm>
+          <a:prstGeom prst="rect">
+            <a:avLst/>
+          </a:prstGeom>
+          <a:noFill/>
+          <a:ln w="0">
+            <a:noFill/>
+          </a:ln>
+        </p:spPr>
+        <p:style>
+          <a:lnRef idx="0"/>
+          <a:fillRef idx="0"/>
+          <a:effectRef idx="0"/>
+          <a:fontRef idx="minor"/>
+        </p:style>
+        <p:txBody>
+          <a:bodyPr lIns="113760" rIns="113760" tIns="454320" bIns="454320" anchor="ctr">
             <a:noAutofit/>
           </a:bodyPr>
           <a:p>
@@ -7994,7 +7994,7 @@
         <p:spPr>
           <a:xfrm>
             <a:off x="6438960" y="4843440"/>
-            <a:ext cx="5264640" cy="492120"/>
+            <a:ext cx="5264280" cy="491760"/>
           </a:xfrm>
           <a:prstGeom prst="rect">
             <a:avLst/>
@@ -8046,7 +8046,7 @@
         <p:spPr>
           <a:xfrm>
             <a:off x="6268320" y="5678640"/>
-            <a:ext cx="5549400" cy="795960"/>
+            <a:ext cx="5549040" cy="795600"/>
           </a:xfrm>
           <a:custGeom>
             <a:avLst/>
@@ -8097,7 +8097,7 @@
         <p:spPr>
           <a:xfrm>
             <a:off x="6268320" y="5678640"/>
-            <a:ext cx="36720" cy="795960"/>
+            <a:ext cx="36360" cy="795600"/>
           </a:xfrm>
           <a:custGeom>
             <a:avLst/>
@@ -8148,7 +8148,7 @@
         <p:spPr>
           <a:xfrm>
             <a:off x="6438960" y="5830200"/>
-            <a:ext cx="5302800" cy="492120"/>
+            <a:ext cx="5302440" cy="491760"/>
           </a:xfrm>
           <a:prstGeom prst="rect">
             <a:avLst/>
@@ -8247,7 +8247,7 @@
         <p:spPr>
           <a:xfrm>
             <a:off x="609480" y="2066760"/>
-            <a:ext cx="12191040" cy="1218240"/>
+            <a:ext cx="12190680" cy="1217880"/>
           </a:xfrm>
           <a:prstGeom prst="rect">
             <a:avLst/>
@@ -8301,7 +8301,7 @@
         <p:spPr>
           <a:xfrm>
             <a:off x="609480" y="3438360"/>
-            <a:ext cx="11867040" cy="570600"/>
+            <a:ext cx="11866680" cy="570240"/>
           </a:xfrm>
           <a:prstGeom prst="rect">
             <a:avLst/>
@@ -8353,7 +8353,7 @@
         <p:spPr>
           <a:xfrm>
             <a:off x="609480" y="4238640"/>
-            <a:ext cx="1218240" cy="18000"/>
+            <a:ext cx="1217880" cy="17640"/>
           </a:xfrm>
           <a:custGeom>
             <a:avLst/>
@@ -8404,7 +8404,7 @@
         <p:spPr>
           <a:xfrm>
             <a:off x="609480" y="4486320"/>
-            <a:ext cx="11695680" cy="303840"/>
+            <a:ext cx="11695320" cy="303480"/>
           </a:xfrm>
           <a:prstGeom prst="rect">
             <a:avLst/>
@@ -8493,7 +8493,7 @@
         <p:spPr>
           <a:xfrm>
             <a:off x="356400" y="356400"/>
-            <a:ext cx="11549880" cy="212760"/>
+            <a:ext cx="11549520" cy="212400"/>
           </a:xfrm>
           <a:prstGeom prst="rect">
             <a:avLst/>
@@ -8521,7 +8521,7 @@
               <a:buNone/>
             </a:pPr>
             <a:r>
-              <a:rPr b="1" lang="en-US" sz="1120" spc="49" strike="noStrike">
+              <a:rPr b="1" lang="en-US" sz="1120" spc="46" strike="noStrike">
                 <a:solidFill>
                   <a:srgbClr val="0984e3"/>
                 </a:solidFill>
@@ -8545,7 +8545,7 @@
         <p:spPr>
           <a:xfrm>
             <a:off x="356400" y="641160"/>
-            <a:ext cx="11692080" cy="426240"/>
+            <a:ext cx="11691720" cy="425880"/>
           </a:xfrm>
           <a:prstGeom prst="rect">
             <a:avLst/>
@@ -8597,7 +8597,7 @@
         <p:spPr>
           <a:xfrm>
             <a:off x="360720" y="1287000"/>
-            <a:ext cx="3694680" cy="2626200"/>
+            <a:ext cx="3694320" cy="2625840"/>
           </a:xfrm>
           <a:custGeom>
             <a:avLst/>
@@ -8651,7 +8651,7 @@
         <p:spPr>
           <a:xfrm>
             <a:off x="543240" y="1469520"/>
-            <a:ext cx="426240" cy="426240"/>
+            <a:ext cx="425880" cy="425880"/>
           </a:xfrm>
           <a:custGeom>
             <a:avLst/>
@@ -8702,7 +8702,7 @@
         <p:spPr>
           <a:xfrm>
             <a:off x="656640" y="1594080"/>
-            <a:ext cx="199440" cy="177120"/>
+            <a:ext cx="199080" cy="176760"/>
           </a:xfrm>
           <a:custGeom>
             <a:avLst/>
@@ -8899,7 +8899,7 @@
         <p:spPr>
           <a:xfrm>
             <a:off x="1077480" y="1558440"/>
-            <a:ext cx="2341080" cy="248400"/>
+            <a:ext cx="2340720" cy="248040"/>
           </a:xfrm>
           <a:prstGeom prst="rect">
             <a:avLst/>
@@ -8951,7 +8951,7 @@
         <p:spPr>
           <a:xfrm>
             <a:off x="543240" y="2003760"/>
-            <a:ext cx="3400920" cy="693720"/>
+            <a:ext cx="3400560" cy="693360"/>
           </a:xfrm>
           <a:prstGeom prst="rect">
             <a:avLst/>
@@ -9013,7 +9013,7 @@
         <p:spPr>
           <a:xfrm>
             <a:off x="543240" y="2805480"/>
-            <a:ext cx="3400920" cy="925200"/>
+            <a:ext cx="3400560" cy="924840"/>
           </a:xfrm>
           <a:prstGeom prst="rect">
             <a:avLst/>
@@ -9075,7 +9075,7 @@
         <p:spPr>
           <a:xfrm>
             <a:off x="4246200" y="1287000"/>
-            <a:ext cx="3694680" cy="2626200"/>
+            <a:ext cx="3694320" cy="2625840"/>
           </a:xfrm>
           <a:custGeom>
             <a:avLst/>
@@ -9129,7 +9129,7 @@
         <p:spPr>
           <a:xfrm>
             <a:off x="4428720" y="1469520"/>
-            <a:ext cx="426240" cy="426240"/>
+            <a:ext cx="425880" cy="425880"/>
           </a:xfrm>
           <a:custGeom>
             <a:avLst/>
@@ -9180,7 +9180,7 @@
         <p:spPr>
           <a:xfrm>
             <a:off x="4542120" y="1594080"/>
-            <a:ext cx="199440" cy="177120"/>
+            <a:ext cx="199080" cy="176760"/>
           </a:xfrm>
           <a:custGeom>
             <a:avLst/>
@@ -9332,7 +9332,7 @@
         <p:spPr>
           <a:xfrm>
             <a:off x="4962960" y="1558440"/>
-            <a:ext cx="2430360" cy="248400"/>
+            <a:ext cx="2430000" cy="248040"/>
           </a:xfrm>
           <a:prstGeom prst="rect">
             <a:avLst/>
@@ -9384,7 +9384,7 @@
         <p:spPr>
           <a:xfrm>
             <a:off x="4428720" y="2003760"/>
-            <a:ext cx="3400920" cy="693720"/>
+            <a:ext cx="3400560" cy="693360"/>
           </a:xfrm>
           <a:prstGeom prst="rect">
             <a:avLst/>
@@ -9446,7 +9446,7 @@
         <p:spPr>
           <a:xfrm>
             <a:off x="4428720" y="2805480"/>
-            <a:ext cx="3400920" cy="693720"/>
+            <a:ext cx="3400560" cy="693360"/>
           </a:xfrm>
           <a:prstGeom prst="rect">
             <a:avLst/>
@@ -9508,7 +9508,7 @@
         <p:spPr>
           <a:xfrm>
             <a:off x="8131680" y="1287000"/>
-            <a:ext cx="3694680" cy="2626200"/>
+            <a:ext cx="3694320" cy="2625840"/>
           </a:xfrm>
           <a:custGeom>
             <a:avLst/>
@@ -9562,7 +9562,7 @@
         <p:spPr>
           <a:xfrm>
             <a:off x="8314200" y="1469520"/>
-            <a:ext cx="426240" cy="426240"/>
+            <a:ext cx="425880" cy="425880"/>
           </a:xfrm>
           <a:custGeom>
             <a:avLst/>
@@ -9613,7 +9613,7 @@
         <p:spPr>
           <a:xfrm>
             <a:off x="8439120" y="1594080"/>
-            <a:ext cx="177120" cy="177120"/>
+            <a:ext cx="176760" cy="176760"/>
           </a:xfrm>
           <a:custGeom>
             <a:avLst/>
@@ -9713,7 +9713,7 @@
         <p:spPr>
           <a:xfrm>
             <a:off x="8848800" y="1558440"/>
-            <a:ext cx="2038320" cy="248400"/>
+            <a:ext cx="2037960" cy="248040"/>
           </a:xfrm>
           <a:prstGeom prst="rect">
             <a:avLst/>
@@ -9765,7 +9765,7 @@
         <p:spPr>
           <a:xfrm>
             <a:off x="8314200" y="2003760"/>
-            <a:ext cx="3400920" cy="693720"/>
+            <a:ext cx="3400560" cy="693360"/>
           </a:xfrm>
           <a:prstGeom prst="rect">
             <a:avLst/>
@@ -9827,7 +9827,7 @@
         <p:spPr>
           <a:xfrm>
             <a:off x="8314200" y="2805480"/>
-            <a:ext cx="3400920" cy="693720"/>
+            <a:ext cx="3400560" cy="693360"/>
           </a:xfrm>
           <a:prstGeom prst="rect">
             <a:avLst/>
@@ -9889,7 +9889,7 @@
         <p:spPr>
           <a:xfrm>
             <a:off x="360720" y="4101120"/>
-            <a:ext cx="3694680" cy="2394720"/>
+            <a:ext cx="3694320" cy="2394360"/>
           </a:xfrm>
           <a:custGeom>
             <a:avLst/>
@@ -9943,7 +9943,7 @@
         <p:spPr>
           <a:xfrm>
             <a:off x="543240" y="4283640"/>
-            <a:ext cx="426240" cy="426240"/>
+            <a:ext cx="425880" cy="425880"/>
           </a:xfrm>
           <a:custGeom>
             <a:avLst/>
@@ -9994,7 +9994,7 @@
         <p:spPr>
           <a:xfrm>
             <a:off x="645840" y="4408200"/>
-            <a:ext cx="221400" cy="177120"/>
+            <a:ext cx="221040" cy="176760"/>
           </a:xfrm>
           <a:custGeom>
             <a:avLst/>
@@ -10226,7 +10226,7 @@
         <p:spPr>
           <a:xfrm>
             <a:off x="1077480" y="4372560"/>
-            <a:ext cx="1931400" cy="248400"/>
+            <a:ext cx="1931040" cy="248040"/>
           </a:xfrm>
           <a:prstGeom prst="rect">
             <a:avLst/>
@@ -10278,7 +10278,7 @@
         <p:spPr>
           <a:xfrm>
             <a:off x="543240" y="4817880"/>
-            <a:ext cx="3400920" cy="693720"/>
+            <a:ext cx="3400560" cy="693360"/>
           </a:xfrm>
           <a:prstGeom prst="rect">
             <a:avLst/>
@@ -10340,7 +10340,7 @@
         <p:spPr>
           <a:xfrm>
             <a:off x="543240" y="5619600"/>
-            <a:ext cx="3400920" cy="693720"/>
+            <a:ext cx="3400560" cy="693360"/>
           </a:xfrm>
           <a:prstGeom prst="rect">
             <a:avLst/>
@@ -10402,7 +10402,7 @@
         <p:spPr>
           <a:xfrm>
             <a:off x="4246200" y="4101120"/>
-            <a:ext cx="7586640" cy="2394720"/>
+            <a:ext cx="7586280" cy="2394360"/>
           </a:xfrm>
           <a:custGeom>
             <a:avLst/>
@@ -10456,7 +10456,7 @@
         <p:spPr>
           <a:xfrm>
             <a:off x="4428720" y="4283640"/>
-            <a:ext cx="426240" cy="426240"/>
+            <a:ext cx="425880" cy="425880"/>
           </a:xfrm>
           <a:custGeom>
             <a:avLst/>
@@ -10507,7 +10507,7 @@
         <p:spPr>
           <a:xfrm>
             <a:off x="4553280" y="4408200"/>
-            <a:ext cx="177120" cy="177120"/>
+            <a:ext cx="176760" cy="176760"/>
           </a:xfrm>
           <a:custGeom>
             <a:avLst/>
@@ -10640,7 +10640,7 @@
         <p:spPr>
           <a:xfrm>
             <a:off x="4962960" y="4372560"/>
-            <a:ext cx="2047320" cy="248400"/>
+            <a:ext cx="2046960" cy="248040"/>
           </a:xfrm>
           <a:prstGeom prst="rect">
             <a:avLst/>
@@ -10692,7 +10692,7 @@
         <p:spPr>
           <a:xfrm>
             <a:off x="4428720" y="4817880"/>
-            <a:ext cx="3605760" cy="693720"/>
+            <a:ext cx="3605400" cy="693360"/>
           </a:xfrm>
           <a:prstGeom prst="rect">
             <a:avLst/>
@@ -10754,7 +10754,7 @@
         <p:spPr>
           <a:xfrm>
             <a:off x="4428720" y="5583960"/>
-            <a:ext cx="3605760" cy="461880"/>
+            <a:ext cx="3605400" cy="461520"/>
           </a:xfrm>
           <a:prstGeom prst="rect">
             <a:avLst/>
@@ -10806,7 +10806,7 @@
         <p:spPr>
           <a:xfrm>
             <a:off x="8109360" y="4817880"/>
-            <a:ext cx="3605760" cy="693720"/>
+            <a:ext cx="3605400" cy="693360"/>
           </a:xfrm>
           <a:prstGeom prst="rect">
             <a:avLst/>
@@ -10868,7 +10868,7 @@
         <p:spPr>
           <a:xfrm>
             <a:off x="8109360" y="5583960"/>
-            <a:ext cx="3605760" cy="461880"/>
+            <a:ext cx="3605400" cy="461520"/>
           </a:xfrm>
           <a:prstGeom prst="rect">
             <a:avLst/>
@@ -10957,7 +10957,7 @@
         <p:spPr>
           <a:xfrm>
             <a:off x="609480" y="2066760"/>
-            <a:ext cx="12191040" cy="1218240"/>
+            <a:ext cx="12190680" cy="1217880"/>
           </a:xfrm>
           <a:prstGeom prst="rect">
             <a:avLst/>
@@ -11011,7 +11011,7 @@
         <p:spPr>
           <a:xfrm>
             <a:off x="609480" y="3438360"/>
-            <a:ext cx="11867040" cy="570600"/>
+            <a:ext cx="11866680" cy="570240"/>
           </a:xfrm>
           <a:prstGeom prst="rect">
             <a:avLst/>
@@ -11063,7 +11063,7 @@
         <p:spPr>
           <a:xfrm>
             <a:off x="609480" y="4238640"/>
-            <a:ext cx="1218240" cy="18000"/>
+            <a:ext cx="1217880" cy="17640"/>
           </a:xfrm>
           <a:custGeom>
             <a:avLst/>
@@ -11114,7 +11114,7 @@
         <p:spPr>
           <a:xfrm>
             <a:off x="609480" y="4486320"/>
-            <a:ext cx="11695680" cy="303840"/>
+            <a:ext cx="11695320" cy="303480"/>
           </a:xfrm>
           <a:prstGeom prst="rect">
             <a:avLst/>
@@ -11203,7 +11203,7 @@
         <p:spPr>
           <a:xfrm>
             <a:off x="380880" y="380880"/>
-            <a:ext cx="11505240" cy="227520"/>
+            <a:ext cx="11504880" cy="227160"/>
           </a:xfrm>
           <a:prstGeom prst="rect">
             <a:avLst/>
@@ -11231,7 +11231,7 @@
               <a:buNone/>
             </a:pPr>
             <a:r>
-              <a:rPr b="1" lang="en-US" sz="1200" spc="52" strike="noStrike">
+              <a:rPr b="1" lang="en-US" sz="1200" spc="49" strike="noStrike">
                 <a:solidFill>
                   <a:srgbClr val="0984e3"/>
                 </a:solidFill>
@@ -11255,7 +11255,7 @@
         <p:spPr>
           <a:xfrm>
             <a:off x="380880" y="685800"/>
-            <a:ext cx="11657520" cy="456120"/>
+            <a:ext cx="11657160" cy="455760"/>
           </a:xfrm>
           <a:prstGeom prst="rect">
             <a:avLst/>
@@ -11307,7 +11307,7 @@
         <p:spPr>
           <a:xfrm>
             <a:off x="380880" y="1295280"/>
-            <a:ext cx="5656680" cy="1237320"/>
+            <a:ext cx="5656320" cy="1236960"/>
           </a:xfrm>
           <a:prstGeom prst="rect">
             <a:avLst/>
@@ -11369,7 +11369,7 @@
         <p:spPr>
           <a:xfrm>
             <a:off x="380880" y="2647800"/>
-            <a:ext cx="5637600" cy="741960"/>
+            <a:ext cx="5637240" cy="741600"/>
           </a:xfrm>
           <a:prstGeom prst="rect">
             <a:avLst/>
@@ -11421,7 +11421,7 @@
         <p:spPr>
           <a:xfrm>
             <a:off x="385920" y="3548160"/>
-            <a:ext cx="5551920" cy="2027880"/>
+            <a:ext cx="5551560" cy="2027520"/>
           </a:xfrm>
           <a:custGeom>
             <a:avLst/>
@@ -11475,7 +11475,7 @@
         <p:spPr>
           <a:xfrm>
             <a:off x="495360" y="3705120"/>
-            <a:ext cx="5333040" cy="265680"/>
+            <a:ext cx="5332680" cy="265320"/>
           </a:xfrm>
           <a:prstGeom prst="rect">
             <a:avLst/>
@@ -12001,7 +12001,7 @@
         <p:spPr>
           <a:xfrm>
             <a:off x="509760" y="5229360"/>
-            <a:ext cx="5304240" cy="189360"/>
+            <a:ext cx="5303880" cy="189000"/>
           </a:xfrm>
           <a:prstGeom prst="rect">
             <a:avLst/>
@@ -12053,7 +12053,7 @@
         <p:spPr>
           <a:xfrm>
             <a:off x="6253200" y="1300320"/>
-            <a:ext cx="5551920" cy="1608480"/>
+            <a:ext cx="5551560" cy="1608120"/>
           </a:xfrm>
           <a:custGeom>
             <a:avLst/>
@@ -12107,7 +12107,7 @@
         <p:spPr>
           <a:xfrm>
             <a:off x="6448320" y="1495440"/>
-            <a:ext cx="5256720" cy="265680"/>
+            <a:ext cx="5256360" cy="265320"/>
           </a:xfrm>
           <a:prstGeom prst="rect">
             <a:avLst/>
@@ -12159,7 +12159,7 @@
         <p:spPr>
           <a:xfrm>
             <a:off x="6448320" y="1876320"/>
-            <a:ext cx="5237640" cy="227520"/>
+            <a:ext cx="5237280" cy="227160"/>
           </a:xfrm>
           <a:prstGeom prst="rect">
             <a:avLst/>
@@ -12221,7 +12221,7 @@
         <p:spPr>
           <a:xfrm>
             <a:off x="6448320" y="2181240"/>
-            <a:ext cx="5237640" cy="227520"/>
+            <a:ext cx="5237280" cy="227160"/>
           </a:xfrm>
           <a:prstGeom prst="rect">
             <a:avLst/>
@@ -12283,7 +12283,7 @@
         <p:spPr>
           <a:xfrm>
             <a:off x="6448320" y="2486160"/>
-            <a:ext cx="5237640" cy="227520"/>
+            <a:ext cx="5237280" cy="227160"/>
           </a:xfrm>
           <a:prstGeom prst="rect">
             <a:avLst/>
@@ -12335,7 +12335,7 @@
         <p:spPr>
           <a:xfrm>
             <a:off x="6267600" y="3067200"/>
-            <a:ext cx="5542560" cy="2132640"/>
+            <a:ext cx="5542200" cy="2132280"/>
           </a:xfrm>
           <a:custGeom>
             <a:avLst/>
@@ -12386,7 +12386,7 @@
         <p:spPr>
           <a:xfrm>
             <a:off x="6267600" y="3067200"/>
-            <a:ext cx="37080" cy="2132640"/>
+            <a:ext cx="36720" cy="2132280"/>
           </a:xfrm>
           <a:custGeom>
             <a:avLst/>
@@ -12437,7 +12437,7 @@
         <p:spPr>
           <a:xfrm>
             <a:off x="6477120" y="3257640"/>
-            <a:ext cx="5237640" cy="265680"/>
+            <a:ext cx="5237280" cy="265320"/>
           </a:xfrm>
           <a:prstGeom prst="rect">
             <a:avLst/>
@@ -12489,7 +12489,7 @@
         <p:spPr>
           <a:xfrm>
             <a:off x="6496200" y="3672000"/>
-            <a:ext cx="151200" cy="151200"/>
+            <a:ext cx="150840" cy="150840"/>
           </a:xfrm>
           <a:custGeom>
             <a:avLst/>
@@ -12613,7 +12613,7 @@
         <p:spPr>
           <a:xfrm>
             <a:off x="6724800" y="3638520"/>
-            <a:ext cx="4970880" cy="456120"/>
+            <a:ext cx="4970520" cy="455760"/>
           </a:xfrm>
           <a:prstGeom prst="rect">
             <a:avLst/>
@@ -12675,7 +12675,7 @@
         <p:spPr>
           <a:xfrm>
             <a:off x="6496200" y="4205160"/>
-            <a:ext cx="151200" cy="151200"/>
+            <a:ext cx="150840" cy="150840"/>
           </a:xfrm>
           <a:custGeom>
             <a:avLst/>
@@ -12798,7 +12798,7 @@
         <p:spPr>
           <a:xfrm>
             <a:off x="6724800" y="4172040"/>
-            <a:ext cx="4970880" cy="227520"/>
+            <a:ext cx="4970520" cy="227160"/>
           </a:xfrm>
           <a:prstGeom prst="rect">
             <a:avLst/>
@@ -12860,7 +12860,7 @@
         <p:spPr>
           <a:xfrm>
             <a:off x="6515280" y="4510080"/>
-            <a:ext cx="113400" cy="151200"/>
+            <a:ext cx="113040" cy="150840"/>
           </a:xfrm>
           <a:custGeom>
             <a:avLst/>
@@ -13101,7 +13101,7 @@
         <p:spPr>
           <a:xfrm>
             <a:off x="6724800" y="4476600"/>
-            <a:ext cx="4970880" cy="227520"/>
+            <a:ext cx="4970520" cy="227160"/>
           </a:xfrm>
           <a:prstGeom prst="rect">
             <a:avLst/>
@@ -13163,7 +13163,7 @@
         <p:spPr>
           <a:xfrm>
             <a:off x="6486480" y="4815000"/>
-            <a:ext cx="170280" cy="151200"/>
+            <a:ext cx="169920" cy="150840"/>
           </a:xfrm>
           <a:custGeom>
             <a:avLst/>
@@ -13399,7 +13399,7 @@
         <p:spPr>
           <a:xfrm>
             <a:off x="6724800" y="4781520"/>
-            <a:ext cx="4970880" cy="227520"/>
+            <a:ext cx="4970520" cy="227160"/>
           </a:xfrm>
           <a:prstGeom prst="rect">
             <a:avLst/>
@@ -13498,7 +13498,7 @@
         <p:spPr>
           <a:xfrm>
             <a:off x="358560" y="358560"/>
-            <a:ext cx="11545560" cy="214200"/>
+            <a:ext cx="11545200" cy="213840"/>
           </a:xfrm>
           <a:prstGeom prst="rect">
             <a:avLst/>
@@ -13526,7 +13526,7 @@
               <a:buNone/>
             </a:pPr>
             <a:r>
-              <a:rPr b="1" lang="en-US" sz="1130" spc="49" strike="noStrike">
+              <a:rPr b="1" lang="en-US" sz="1130" spc="46" strike="noStrike">
                 <a:solidFill>
                   <a:srgbClr val="0984e3"/>
                 </a:solidFill>
@@ -13550,7 +13550,7 @@
         <p:spPr>
           <a:xfrm>
             <a:off x="358560" y="645480"/>
-            <a:ext cx="11688840" cy="429120"/>
+            <a:ext cx="11688480" cy="428760"/>
           </a:xfrm>
           <a:prstGeom prst="rect">
             <a:avLst/>
@@ -13602,7 +13602,7 @@
         <p:spPr>
           <a:xfrm>
             <a:off x="358560" y="1290960"/>
-            <a:ext cx="5700600" cy="285840"/>
+            <a:ext cx="5700240" cy="285480"/>
           </a:xfrm>
           <a:prstGeom prst="rect">
             <a:avLst/>
@@ -13654,7 +13654,7 @@
         <p:spPr>
           <a:xfrm>
             <a:off x="358560" y="1725840"/>
-            <a:ext cx="5473440" cy="440280"/>
+            <a:ext cx="5473080" cy="439920"/>
           </a:xfrm>
           <a:prstGeom prst="rect">
             <a:avLst/>
@@ -13706,7 +13706,7 @@
         <p:spPr>
           <a:xfrm>
             <a:off x="358560" y="2317320"/>
-            <a:ext cx="5664600" cy="465120"/>
+            <a:ext cx="5664240" cy="464760"/>
           </a:xfrm>
           <a:prstGeom prst="rect">
             <a:avLst/>
@@ -13758,7 +13758,7 @@
         <p:spPr>
           <a:xfrm>
             <a:off x="363240" y="2931480"/>
-            <a:ext cx="5583960" cy="1872720"/>
+            <a:ext cx="5583600" cy="1872360"/>
           </a:xfrm>
           <a:custGeom>
             <a:avLst/>
@@ -13812,7 +13812,7 @@
         <p:spPr>
           <a:xfrm>
             <a:off x="470520" y="3079440"/>
-            <a:ext cx="5368680" cy="249840"/>
+            <a:ext cx="5368320" cy="249480"/>
           </a:xfrm>
           <a:prstGeom prst="rect">
             <a:avLst/>
@@ -14340,7 +14340,7 @@
         <p:spPr>
           <a:xfrm>
             <a:off x="479520" y="4478040"/>
-            <a:ext cx="5350680" cy="178200"/>
+            <a:ext cx="5350320" cy="177840"/>
           </a:xfrm>
           <a:prstGeom prst="rect">
             <a:avLst/>
@@ -14392,7 +14392,7 @@
         <p:spPr>
           <a:xfrm>
             <a:off x="376560" y="4952880"/>
-            <a:ext cx="5574960" cy="752040"/>
+            <a:ext cx="5574600" cy="751680"/>
           </a:xfrm>
           <a:custGeom>
             <a:avLst/>
@@ -14443,7 +14443,7 @@
         <p:spPr>
           <a:xfrm>
             <a:off x="376560" y="4952880"/>
-            <a:ext cx="34920" cy="752040"/>
+            <a:ext cx="34560" cy="751680"/>
           </a:xfrm>
           <a:custGeom>
             <a:avLst/>
@@ -14494,7 +14494,7 @@
         <p:spPr>
           <a:xfrm>
             <a:off x="537840" y="5096520"/>
-            <a:ext cx="5342040" cy="465120"/>
+            <a:ext cx="5341680" cy="464760"/>
           </a:xfrm>
           <a:prstGeom prst="rect">
             <a:avLst/>
@@ -14556,7 +14556,7 @@
         <p:spPr>
           <a:xfrm>
             <a:off x="6239520" y="1290960"/>
-            <a:ext cx="5700600" cy="285840"/>
+            <a:ext cx="5700240" cy="285480"/>
           </a:xfrm>
           <a:prstGeom prst="rect">
             <a:avLst/>
@@ -14608,7 +14608,7 @@
         <p:spPr>
           <a:xfrm>
             <a:off x="6239520" y="1685520"/>
-            <a:ext cx="5673600" cy="527760"/>
+            <a:ext cx="5673240" cy="527400"/>
           </a:xfrm>
           <a:prstGeom prst="rect">
             <a:avLst/>
@@ -14670,7 +14670,7 @@
         <p:spPr>
           <a:xfrm>
             <a:off x="6239520" y="2317320"/>
-            <a:ext cx="5664600" cy="698040"/>
+            <a:ext cx="5664240" cy="697680"/>
           </a:xfrm>
           <a:prstGeom prst="rect">
             <a:avLst/>
@@ -14722,7 +14722,7 @@
         <p:spPr>
           <a:xfrm>
             <a:off x="6243840" y="3164400"/>
-            <a:ext cx="5583960" cy="1872720"/>
+            <a:ext cx="5583600" cy="1872360"/>
           </a:xfrm>
           <a:custGeom>
             <a:avLst/>
@@ -14776,7 +14776,7 @@
         <p:spPr>
           <a:xfrm>
             <a:off x="6351480" y="3312360"/>
-            <a:ext cx="5368680" cy="249840"/>
+            <a:ext cx="5368320" cy="249480"/>
           </a:xfrm>
           <a:prstGeom prst="rect">
             <a:avLst/>
@@ -15302,7 +15302,7 @@
         <p:spPr>
           <a:xfrm>
             <a:off x="6360480" y="4710960"/>
-            <a:ext cx="5350680" cy="178200"/>
+            <a:ext cx="5350320" cy="177840"/>
           </a:xfrm>
           <a:prstGeom prst="rect">
             <a:avLst/>
@@ -15354,7 +15354,7 @@
         <p:spPr>
           <a:xfrm>
             <a:off x="6239520" y="5186160"/>
-            <a:ext cx="5592960" cy="1307880"/>
+            <a:ext cx="5592600" cy="1307520"/>
           </a:xfrm>
           <a:custGeom>
             <a:avLst/>
@@ -15405,7 +15405,7 @@
         <p:spPr>
           <a:xfrm>
             <a:off x="6382800" y="5329440"/>
-            <a:ext cx="5386680" cy="249840"/>
+            <a:ext cx="5386320" cy="249480"/>
           </a:xfrm>
           <a:prstGeom prst="rect">
             <a:avLst/>
@@ -15457,7 +15457,7 @@
         <p:spPr>
           <a:xfrm>
             <a:off x="6382800" y="5652360"/>
-            <a:ext cx="5377680" cy="698040"/>
+            <a:ext cx="5377320" cy="697680"/>
           </a:xfrm>
           <a:prstGeom prst="rect">
             <a:avLst/>
@@ -15546,7 +15546,7 @@
         <p:spPr>
           <a:xfrm>
             <a:off x="609480" y="1781280"/>
-            <a:ext cx="12191040" cy="1218240"/>
+            <a:ext cx="12190680" cy="1217880"/>
           </a:xfrm>
           <a:prstGeom prst="rect">
             <a:avLst/>
@@ -15600,7 +15600,7 @@
         <p:spPr>
           <a:xfrm>
             <a:off x="609480" y="3152880"/>
-            <a:ext cx="11867040" cy="1141920"/>
+            <a:ext cx="11866680" cy="1141560"/>
           </a:xfrm>
           <a:prstGeom prst="rect">
             <a:avLst/>
@@ -15673,7 +15673,7 @@
         <p:spPr>
           <a:xfrm>
             <a:off x="609480" y="4524480"/>
-            <a:ext cx="1218240" cy="18000"/>
+            <a:ext cx="1217880" cy="17640"/>
           </a:xfrm>
           <a:custGeom>
             <a:avLst/>
@@ -15724,7 +15724,7 @@
         <p:spPr>
           <a:xfrm>
             <a:off x="609480" y="4772160"/>
-            <a:ext cx="11695680" cy="303840"/>
+            <a:ext cx="11695320" cy="303480"/>
           </a:xfrm>
           <a:prstGeom prst="rect">
             <a:avLst/>
@@ -15813,7 +15813,7 @@
         <p:spPr>
           <a:xfrm>
             <a:off x="380880" y="380880"/>
-            <a:ext cx="11505240" cy="227520"/>
+            <a:ext cx="11504880" cy="227160"/>
           </a:xfrm>
           <a:prstGeom prst="rect">
             <a:avLst/>
@@ -15841,7 +15841,7 @@
               <a:buNone/>
             </a:pPr>
             <a:r>
-              <a:rPr b="1" lang="en-US" sz="1200" spc="52" strike="noStrike">
+              <a:rPr b="1" lang="en-US" sz="1200" spc="49" strike="noStrike">
                 <a:solidFill>
                   <a:srgbClr val="0984e3"/>
                 </a:solidFill>
@@ -15865,7 +15865,7 @@
         <p:spPr>
           <a:xfrm>
             <a:off x="380880" y="685800"/>
-            <a:ext cx="11657520" cy="456120"/>
+            <a:ext cx="11657160" cy="455760"/>
           </a:xfrm>
           <a:prstGeom prst="rect">
             <a:avLst/>
@@ -15917,7 +15917,7 @@
         <p:spPr>
           <a:xfrm>
             <a:off x="380880" y="1295280"/>
-            <a:ext cx="7647480" cy="932400"/>
+            <a:ext cx="7647120" cy="932040"/>
           </a:xfrm>
           <a:prstGeom prst="rect">
             <a:avLst/>
@@ -15979,7 +15979,7 @@
         <p:spPr>
           <a:xfrm>
             <a:off x="385920" y="2381400"/>
-            <a:ext cx="3694680" cy="1722960"/>
+            <a:ext cx="3694320" cy="1722600"/>
           </a:xfrm>
           <a:custGeom>
             <a:avLst/>
@@ -16033,7 +16033,7 @@
         <p:spPr>
           <a:xfrm>
             <a:off x="542880" y="2538360"/>
-            <a:ext cx="3475440" cy="265680"/>
+            <a:ext cx="3475080" cy="265320"/>
           </a:xfrm>
           <a:prstGeom prst="rect">
             <a:avLst/>
@@ -16085,7 +16085,7 @@
         <p:spPr>
           <a:xfrm>
             <a:off x="542880" y="2881440"/>
-            <a:ext cx="3456360" cy="494280"/>
+            <a:ext cx="3456000" cy="493920"/>
           </a:xfrm>
           <a:prstGeom prst="rect">
             <a:avLst/>
@@ -16147,7 +16147,7 @@
         <p:spPr>
           <a:xfrm>
             <a:off x="542880" y="3452760"/>
-            <a:ext cx="3456360" cy="494280"/>
+            <a:ext cx="3456000" cy="493920"/>
           </a:xfrm>
           <a:prstGeom prst="rect">
             <a:avLst/>
@@ -16209,7 +16209,7 @@
         <p:spPr>
           <a:xfrm>
             <a:off x="4240080" y="2381400"/>
-            <a:ext cx="3694680" cy="1722960"/>
+            <a:ext cx="3694320" cy="1722600"/>
           </a:xfrm>
           <a:custGeom>
             <a:avLst/>
@@ -16263,7 +16263,7 @@
         <p:spPr>
           <a:xfrm>
             <a:off x="4397400" y="2538360"/>
-            <a:ext cx="3475440" cy="265680"/>
+            <a:ext cx="3475080" cy="265320"/>
           </a:xfrm>
           <a:prstGeom prst="rect">
             <a:avLst/>
@@ -16315,7 +16315,7 @@
         <p:spPr>
           <a:xfrm>
             <a:off x="4397400" y="2881440"/>
-            <a:ext cx="3456360" cy="494280"/>
+            <a:ext cx="3456000" cy="493920"/>
           </a:xfrm>
           <a:prstGeom prst="rect">
             <a:avLst/>
@@ -16377,7 +16377,7 @@
         <p:spPr>
           <a:xfrm>
             <a:off x="4397400" y="3452760"/>
-            <a:ext cx="3456360" cy="494280"/>
+            <a:ext cx="3456000" cy="493920"/>
           </a:xfrm>
           <a:prstGeom prst="rect">
             <a:avLst/>
@@ -16439,7 +16439,7 @@
         <p:spPr>
           <a:xfrm>
             <a:off x="399960" y="4262400"/>
-            <a:ext cx="7533360" cy="1637280"/>
+            <a:ext cx="7533000" cy="1636920"/>
           </a:xfrm>
           <a:custGeom>
             <a:avLst/>
@@ -16490,7 +16490,7 @@
         <p:spPr>
           <a:xfrm>
             <a:off x="399960" y="4262400"/>
-            <a:ext cx="37080" cy="1637280"/>
+            <a:ext cx="36720" cy="1636920"/>
           </a:xfrm>
           <a:custGeom>
             <a:avLst/>
@@ -16541,7 +16541,7 @@
         <p:spPr>
           <a:xfrm>
             <a:off x="571680" y="4414680"/>
-            <a:ext cx="7304760" cy="265680"/>
+            <a:ext cx="7304400" cy="265320"/>
           </a:xfrm>
           <a:prstGeom prst="rect">
             <a:avLst/>
@@ -16593,7 +16593,7 @@
         <p:spPr>
           <a:xfrm>
             <a:off x="619200" y="4791240"/>
-            <a:ext cx="94320" cy="151200"/>
+            <a:ext cx="93960" cy="150840"/>
           </a:xfrm>
           <a:custGeom>
             <a:avLst/>
@@ -16748,7 +16748,7 @@
         <p:spPr>
           <a:xfrm>
             <a:off x="819000" y="4757760"/>
-            <a:ext cx="3361320" cy="456120"/>
+            <a:ext cx="3360960" cy="455760"/>
           </a:xfrm>
           <a:prstGeom prst="rect">
             <a:avLst/>
@@ -16810,7 +16810,7 @@
         <p:spPr>
           <a:xfrm>
             <a:off x="4282920" y="4791240"/>
-            <a:ext cx="132120" cy="151200"/>
+            <a:ext cx="131760" cy="150840"/>
           </a:xfrm>
           <a:custGeom>
             <a:avLst/>
@@ -16942,7 +16942,7 @@
         <p:spPr>
           <a:xfrm>
             <a:off x="4502160" y="4757760"/>
-            <a:ext cx="3361320" cy="456120"/>
+            <a:ext cx="3360960" cy="455760"/>
           </a:xfrm>
           <a:prstGeom prst="rect">
             <a:avLst/>
@@ -17004,7 +17004,7 @@
         <p:spPr>
           <a:xfrm>
             <a:off x="590400" y="5324400"/>
-            <a:ext cx="151200" cy="151200"/>
+            <a:ext cx="150840" cy="150840"/>
           </a:xfrm>
           <a:custGeom>
             <a:avLst/>
@@ -17227,7 +17227,7 @@
         <p:spPr>
           <a:xfrm>
             <a:off x="819000" y="5291280"/>
-            <a:ext cx="3361320" cy="456120"/>
+            <a:ext cx="3360960" cy="455760"/>
           </a:xfrm>
           <a:prstGeom prst="rect">
             <a:avLst/>
@@ -17289,7 +17289,7 @@
         <p:spPr>
           <a:xfrm>
             <a:off x="4263840" y="5324400"/>
-            <a:ext cx="170280" cy="151200"/>
+            <a:ext cx="169920" cy="150840"/>
           </a:xfrm>
           <a:custGeom>
             <a:avLst/>
@@ -17486,7 +17486,7 @@
         <p:spPr>
           <a:xfrm>
             <a:off x="4502160" y="5291280"/>
-            <a:ext cx="3361320" cy="456120"/>
+            <a:ext cx="3360960" cy="455760"/>
           </a:xfrm>
           <a:prstGeom prst="rect">
             <a:avLst/>
@@ -17548,7 +17548,7 @@
         <p:spPr>
           <a:xfrm>
             <a:off x="8132760" y="1300320"/>
-            <a:ext cx="3675600" cy="2637360"/>
+            <a:ext cx="3675240" cy="2637000"/>
           </a:xfrm>
           <a:custGeom>
             <a:avLst/>
@@ -17602,7 +17602,7 @@
         <p:spPr>
           <a:xfrm>
             <a:off x="8242200" y="1457280"/>
-            <a:ext cx="3456360" cy="265680"/>
+            <a:ext cx="3456000" cy="265320"/>
           </a:xfrm>
           <a:prstGeom prst="rect">
             <a:avLst/>
@@ -17654,7 +17654,7 @@
         <p:spPr>
           <a:xfrm>
             <a:off x="8289720" y="1838160"/>
-            <a:ext cx="3361320" cy="1332360"/>
+            <a:ext cx="3360960" cy="1332000"/>
           </a:xfrm>
           <a:prstGeom prst="roundRect">
             <a:avLst>
@@ -17686,7 +17686,7 @@
         <p:spPr>
           <a:xfrm>
             <a:off x="8251920" y="3286080"/>
-            <a:ext cx="3437280" cy="494280"/>
+            <a:ext cx="3436920" cy="493920"/>
           </a:xfrm>
           <a:prstGeom prst="rect">
             <a:avLst/>
@@ -17738,7 +17738,7 @@
         <p:spPr>
           <a:xfrm>
             <a:off x="8128080" y="4095720"/>
-            <a:ext cx="3684960" cy="1637280"/>
+            <a:ext cx="3684600" cy="1636920"/>
           </a:xfrm>
           <a:custGeom>
             <a:avLst/>
@@ -17789,7 +17789,7 @@
         <p:spPr>
           <a:xfrm>
             <a:off x="8280360" y="4248000"/>
-            <a:ext cx="3466080" cy="265680"/>
+            <a:ext cx="3465720" cy="265320"/>
           </a:xfrm>
           <a:prstGeom prst="rect">
             <a:avLst/>
@@ -17841,7 +17841,7 @@
         <p:spPr>
           <a:xfrm>
             <a:off x="8280360" y="4591080"/>
-            <a:ext cx="3456360" cy="989640"/>
+            <a:ext cx="3456000" cy="989280"/>
           </a:xfrm>
           <a:prstGeom prst="rect">
             <a:avLst/>
@@ -17930,7 +17930,7 @@
         <p:spPr>
           <a:xfrm>
             <a:off x="370440" y="370440"/>
-            <a:ext cx="11523960" cy="221400"/>
+            <a:ext cx="11523600" cy="221040"/>
           </a:xfrm>
           <a:prstGeom prst="rect">
             <a:avLst/>
@@ -17958,7 +17958,7 @@
               <a:buNone/>
             </a:pPr>
             <a:r>
-              <a:rPr b="1" lang="en-US" sz="1170" spc="49" strike="noStrike">
+              <a:rPr b="1" lang="en-US" sz="1170" spc="46" strike="noStrike">
                 <a:solidFill>
                   <a:srgbClr val="0984e3"/>
                 </a:solidFill>
@@ -17982,7 +17982,7 @@
         <p:spPr>
           <a:xfrm>
             <a:off x="370440" y="667080"/>
-            <a:ext cx="11672280" cy="443520"/>
+            <a:ext cx="11671920" cy="443160"/>
           </a:xfrm>
           <a:prstGeom prst="rect">
             <a:avLst/>
@@ -18034,7 +18034,7 @@
         <p:spPr>
           <a:xfrm>
             <a:off x="370440" y="1334160"/>
-            <a:ext cx="5668920" cy="1203120"/>
+            <a:ext cx="5668560" cy="1202760"/>
           </a:xfrm>
           <a:prstGeom prst="rect">
             <a:avLst/>
@@ -18096,7 +18096,7 @@
         <p:spPr>
           <a:xfrm>
             <a:off x="375120" y="2691360"/>
-            <a:ext cx="5566680" cy="2157480"/>
+            <a:ext cx="5566320" cy="2157120"/>
           </a:xfrm>
           <a:custGeom>
             <a:avLst/>
@@ -18150,7 +18150,7 @@
         <p:spPr>
           <a:xfrm>
             <a:off x="565200" y="2881080"/>
-            <a:ext cx="5279760" cy="258480"/>
+            <a:ext cx="5279400" cy="258120"/>
           </a:xfrm>
           <a:prstGeom prst="rect">
             <a:avLst/>
@@ -18202,7 +18202,7 @@
         <p:spPr>
           <a:xfrm>
             <a:off x="565200" y="3251880"/>
-            <a:ext cx="5261040" cy="480600"/>
+            <a:ext cx="5260680" cy="480240"/>
           </a:xfrm>
           <a:prstGeom prst="rect">
             <a:avLst/>
@@ -18254,7 +18254,7 @@
         <p:spPr>
           <a:xfrm>
             <a:off x="592920" y="3877200"/>
-            <a:ext cx="128520" cy="147240"/>
+            <a:ext cx="128160" cy="146880"/>
           </a:xfrm>
           <a:custGeom>
             <a:avLst/>
@@ -18335,7 +18335,7 @@
         <p:spPr>
           <a:xfrm>
             <a:off x="804600" y="3844800"/>
-            <a:ext cx="5021640" cy="221400"/>
+            <a:ext cx="5021280" cy="221040"/>
           </a:xfrm>
           <a:prstGeom prst="rect">
             <a:avLst/>
@@ -18387,7 +18387,7 @@
         <p:spPr>
           <a:xfrm>
             <a:off x="592920" y="4173480"/>
-            <a:ext cx="128520" cy="147240"/>
+            <a:ext cx="128160" cy="146880"/>
           </a:xfrm>
           <a:custGeom>
             <a:avLst/>
@@ -18468,7 +18468,7 @@
         <p:spPr>
           <a:xfrm>
             <a:off x="804600" y="4141080"/>
-            <a:ext cx="5021640" cy="221400"/>
+            <a:ext cx="5021280" cy="221040"/>
           </a:xfrm>
           <a:prstGeom prst="rect">
             <a:avLst/>
@@ -18520,7 +18520,7 @@
         <p:spPr>
           <a:xfrm>
             <a:off x="592920" y="4470120"/>
-            <a:ext cx="128520" cy="147240"/>
+            <a:ext cx="128160" cy="146880"/>
           </a:xfrm>
           <a:custGeom>
             <a:avLst/>
@@ -18601,7 +18601,7 @@
         <p:spPr>
           <a:xfrm>
             <a:off x="804600" y="4437720"/>
-            <a:ext cx="5021640" cy="221400"/>
+            <a:ext cx="5021280" cy="221040"/>
           </a:xfrm>
           <a:prstGeom prst="rect">
             <a:avLst/>
@@ -18653,7 +18653,7 @@
         <p:spPr>
           <a:xfrm>
             <a:off x="375120" y="5007600"/>
-            <a:ext cx="5566680" cy="1472040"/>
+            <a:ext cx="5566320" cy="1471680"/>
           </a:xfrm>
           <a:custGeom>
             <a:avLst/>
@@ -18707,7 +18707,7 @@
         <p:spPr>
           <a:xfrm>
             <a:off x="565200" y="5197320"/>
-            <a:ext cx="5279760" cy="258480"/>
+            <a:ext cx="5279400" cy="258120"/>
           </a:xfrm>
           <a:prstGeom prst="rect">
             <a:avLst/>
@@ -18759,7 +18759,7 @@
         <p:spPr>
           <a:xfrm>
             <a:off x="565200" y="5567760"/>
-            <a:ext cx="5261040" cy="721440"/>
+            <a:ext cx="5260680" cy="721080"/>
           </a:xfrm>
           <a:prstGeom prst="rect">
             <a:avLst/>
@@ -18811,7 +18811,7 @@
         <p:spPr>
           <a:xfrm>
             <a:off x="6242040" y="1334160"/>
-            <a:ext cx="5576040" cy="2843280"/>
+            <a:ext cx="5575680" cy="2842920"/>
           </a:xfrm>
           <a:custGeom>
             <a:avLst/>
@@ -18862,7 +18862,7 @@
         <p:spPr>
           <a:xfrm>
             <a:off x="6427440" y="1519200"/>
-            <a:ext cx="5316840" cy="295560"/>
+            <a:ext cx="5316480" cy="295200"/>
           </a:xfrm>
           <a:prstGeom prst="rect">
             <a:avLst/>
@@ -18914,7 +18914,7 @@
         <p:spPr>
           <a:xfrm>
             <a:off x="6427440" y="1968840"/>
-            <a:ext cx="5145480" cy="455040"/>
+            <a:ext cx="5145120" cy="454680"/>
           </a:xfrm>
           <a:prstGeom prst="rect">
             <a:avLst/>
@@ -18966,7 +18966,7 @@
         <p:spPr>
           <a:xfrm>
             <a:off x="6427440" y="2580120"/>
-            <a:ext cx="5279760" cy="480600"/>
+            <a:ext cx="5279400" cy="480240"/>
           </a:xfrm>
           <a:prstGeom prst="rect">
             <a:avLst/>
@@ -19018,7 +19018,7 @@
         <p:spPr>
           <a:xfrm>
             <a:off x="6436800" y="3205440"/>
-            <a:ext cx="165600" cy="147240"/>
+            <a:ext cx="165240" cy="146880"/>
           </a:xfrm>
           <a:custGeom>
             <a:avLst/>
@@ -19203,7 +19203,7 @@
         <p:spPr>
           <a:xfrm>
             <a:off x="6666840" y="3173040"/>
-            <a:ext cx="5040360" cy="221400"/>
+            <a:ext cx="5040000" cy="221040"/>
           </a:xfrm>
           <a:prstGeom prst="rect">
             <a:avLst/>
@@ -19265,7 +19265,7 @@
         <p:spPr>
           <a:xfrm>
             <a:off x="6445800" y="3502080"/>
-            <a:ext cx="147240" cy="147240"/>
+            <a:ext cx="146880" cy="146880"/>
           </a:xfrm>
           <a:custGeom>
             <a:avLst/>
@@ -19432,7 +19432,7 @@
         <p:spPr>
           <a:xfrm>
             <a:off x="6666840" y="3469680"/>
-            <a:ext cx="5040360" cy="221400"/>
+            <a:ext cx="5040000" cy="221040"/>
           </a:xfrm>
           <a:prstGeom prst="rect">
             <a:avLst/>
@@ -19494,7 +19494,7 @@
         <p:spPr>
           <a:xfrm>
             <a:off x="6427440" y="3798360"/>
-            <a:ext cx="184320" cy="147240"/>
+            <a:ext cx="183960" cy="146880"/>
           </a:xfrm>
           <a:custGeom>
             <a:avLst/>
@@ -19726,7 +19726,7 @@
         <p:spPr>
           <a:xfrm>
             <a:off x="6666840" y="3765960"/>
-            <a:ext cx="5040360" cy="221400"/>
+            <a:ext cx="5040000" cy="221040"/>
           </a:xfrm>
           <a:prstGeom prst="rect">
             <a:avLst/>
@@ -19788,7 +19788,7 @@
         <p:spPr>
           <a:xfrm>
             <a:off x="6260760" y="4321800"/>
-            <a:ext cx="5557680" cy="869760"/>
+            <a:ext cx="5557320" cy="869400"/>
           </a:xfrm>
           <a:custGeom>
             <a:avLst/>
@@ -19839,7 +19839,7 @@
         <p:spPr>
           <a:xfrm>
             <a:off x="6260760" y="4321800"/>
-            <a:ext cx="36000" cy="869760"/>
+            <a:ext cx="35640" cy="869400"/>
           </a:xfrm>
           <a:custGeom>
             <a:avLst/>
@@ -19890,7 +19890,7 @@
         <p:spPr>
           <a:xfrm>
             <a:off x="6464520" y="4507200"/>
-            <a:ext cx="5242680" cy="239760"/>
+            <a:ext cx="5242320" cy="239400"/>
           </a:xfrm>
           <a:prstGeom prst="rect">
             <a:avLst/>
@@ -19942,7 +19942,7 @@
         <p:spPr>
           <a:xfrm>
             <a:off x="6464520" y="4822200"/>
-            <a:ext cx="5233320" cy="184320"/>
+            <a:ext cx="5232960" cy="183960"/>
           </a:xfrm>
           <a:prstGeom prst="rect">
             <a:avLst/>
@@ -20041,7 +20041,7 @@
         <p:spPr>
           <a:xfrm>
             <a:off x="380880" y="380880"/>
-            <a:ext cx="11657520" cy="456120"/>
+            <a:ext cx="11657160" cy="455760"/>
           </a:xfrm>
           <a:prstGeom prst="rect">
             <a:avLst/>
@@ -20093,7 +20093,7 @@
         <p:spPr>
           <a:xfrm>
             <a:off x="380880" y="952560"/>
-            <a:ext cx="761040" cy="18000"/>
+            <a:ext cx="760680" cy="17640"/>
           </a:xfrm>
           <a:custGeom>
             <a:avLst/>
@@ -20144,7 +20144,7 @@
         <p:spPr>
           <a:xfrm>
             <a:off x="380880" y="1428840"/>
-            <a:ext cx="751320" cy="570600"/>
+            <a:ext cx="750960" cy="570240"/>
           </a:xfrm>
           <a:prstGeom prst="rect">
             <a:avLst/>
@@ -20198,7 +20198,7 @@
         <p:spPr>
           <a:xfrm>
             <a:off x="1034280" y="1504800"/>
-            <a:ext cx="4190040" cy="303840"/>
+            <a:ext cx="4189680" cy="303480"/>
           </a:xfrm>
           <a:prstGeom prst="rect">
             <a:avLst/>
@@ -20250,7 +20250,7 @@
         <p:spPr>
           <a:xfrm>
             <a:off x="1034280" y="1886040"/>
-            <a:ext cx="4161240" cy="275040"/>
+            <a:ext cx="4160880" cy="274680"/>
           </a:xfrm>
           <a:prstGeom prst="rect">
             <a:avLst/>
@@ -20302,7 +20302,7 @@
         <p:spPr>
           <a:xfrm>
             <a:off x="6400800" y="1428840"/>
-            <a:ext cx="856080" cy="570600"/>
+            <a:ext cx="855720" cy="570240"/>
           </a:xfrm>
           <a:prstGeom prst="rect">
             <a:avLst/>
@@ -20356,7 +20356,7 @@
         <p:spPr>
           <a:xfrm>
             <a:off x="7160040" y="1504800"/>
-            <a:ext cx="4761360" cy="303840"/>
+            <a:ext cx="4761000" cy="303480"/>
           </a:xfrm>
           <a:prstGeom prst="rect">
             <a:avLst/>
@@ -20408,7 +20408,7 @@
         <p:spPr>
           <a:xfrm>
             <a:off x="7160040" y="1886040"/>
-            <a:ext cx="4732920" cy="560880"/>
+            <a:ext cx="4732560" cy="560520"/>
           </a:xfrm>
           <a:prstGeom prst="rect">
             <a:avLst/>
@@ -20460,7 +20460,7 @@
         <p:spPr>
           <a:xfrm>
             <a:off x="380880" y="2824200"/>
-            <a:ext cx="856080" cy="570600"/>
+            <a:ext cx="855720" cy="570240"/>
           </a:xfrm>
           <a:prstGeom prst="rect">
             <a:avLst/>
@@ -20514,7 +20514,7 @@
         <p:spPr>
           <a:xfrm>
             <a:off x="1143000" y="2900520"/>
-            <a:ext cx="3970800" cy="303840"/>
+            <a:ext cx="3970440" cy="303480"/>
           </a:xfrm>
           <a:prstGeom prst="rect">
             <a:avLst/>
@@ -20566,7 +20566,7 @@
         <p:spPr>
           <a:xfrm>
             <a:off x="1143000" y="3281400"/>
-            <a:ext cx="3942360" cy="275040"/>
+            <a:ext cx="3942000" cy="274680"/>
           </a:xfrm>
           <a:prstGeom prst="rect">
             <a:avLst/>
@@ -20618,7 +20618,7 @@
         <p:spPr>
           <a:xfrm>
             <a:off x="6400800" y="2824200"/>
-            <a:ext cx="884880" cy="570600"/>
+            <a:ext cx="884520" cy="570240"/>
           </a:xfrm>
           <a:prstGeom prst="rect">
             <a:avLst/>
@@ -20672,7 +20672,7 @@
         <p:spPr>
           <a:xfrm>
             <a:off x="7188480" y="2900520"/>
-            <a:ext cx="2475360" cy="303840"/>
+            <a:ext cx="2475000" cy="303480"/>
           </a:xfrm>
           <a:prstGeom prst="rect">
             <a:avLst/>
@@ -20724,7 +20724,7 @@
         <p:spPr>
           <a:xfrm>
             <a:off x="7188480" y="3281400"/>
-            <a:ext cx="2446920" cy="275040"/>
+            <a:ext cx="2446560" cy="274680"/>
           </a:xfrm>
           <a:prstGeom prst="rect">
             <a:avLst/>
@@ -20776,7 +20776,7 @@
         <p:spPr>
           <a:xfrm>
             <a:off x="380880" y="3940920"/>
-            <a:ext cx="846720" cy="570600"/>
+            <a:ext cx="846360" cy="570240"/>
           </a:xfrm>
           <a:prstGeom prst="rect">
             <a:avLst/>
@@ -20830,7 +20830,7 @@
         <p:spPr>
           <a:xfrm>
             <a:off x="1137240" y="4017240"/>
-            <a:ext cx="2865960" cy="303840"/>
+            <a:ext cx="2865600" cy="303480"/>
           </a:xfrm>
           <a:prstGeom prst="rect">
             <a:avLst/>
@@ -20882,7 +20882,7 @@
         <p:spPr>
           <a:xfrm>
             <a:off x="1137240" y="4398120"/>
-            <a:ext cx="2837520" cy="275040"/>
+            <a:ext cx="2837160" cy="274680"/>
           </a:xfrm>
           <a:prstGeom prst="rect">
             <a:avLst/>
@@ -20934,7 +20934,7 @@
         <p:spPr>
           <a:xfrm>
             <a:off x="6400800" y="3940920"/>
-            <a:ext cx="865800" cy="570600"/>
+            <a:ext cx="865440" cy="570240"/>
           </a:xfrm>
           <a:prstGeom prst="rect">
             <a:avLst/>
@@ -20988,7 +20988,7 @@
         <p:spPr>
           <a:xfrm>
             <a:off x="7171560" y="4017240"/>
-            <a:ext cx="3075480" cy="303840"/>
+            <a:ext cx="3075120" cy="303480"/>
           </a:xfrm>
           <a:prstGeom prst="rect">
             <a:avLst/>
@@ -21040,7 +21040,7 @@
         <p:spPr>
           <a:xfrm>
             <a:off x="7171560" y="4398120"/>
-            <a:ext cx="3047040" cy="275040"/>
+            <a:ext cx="3046680" cy="274680"/>
           </a:xfrm>
           <a:prstGeom prst="rect">
             <a:avLst/>
@@ -21129,7 +21129,7 @@
         <p:spPr>
           <a:xfrm>
             <a:off x="335880" y="335880"/>
-            <a:ext cx="11586240" cy="200520"/>
+            <a:ext cx="11585880" cy="200160"/>
           </a:xfrm>
           <a:prstGeom prst="rect">
             <a:avLst/>
@@ -21157,7 +21157,7 @@
               <a:buNone/>
             </a:pPr>
             <a:r>
-              <a:rPr b="1" lang="en-US" sz="1060" spc="46" strike="noStrike">
+              <a:rPr b="1" lang="en-US" sz="1060" spc="43" strike="noStrike">
                 <a:solidFill>
                   <a:srgbClr val="0984e3"/>
                 </a:solidFill>
@@ -21181,7 +21181,7 @@
         <p:spPr>
           <a:xfrm>
             <a:off x="335880" y="604440"/>
-            <a:ext cx="11720880" cy="402120"/>
+            <a:ext cx="11720520" cy="401760"/>
           </a:xfrm>
           <a:prstGeom prst="rect">
             <a:avLst/>
@@ -21233,7 +21233,7 @@
         <p:spPr>
           <a:xfrm>
             <a:off x="335880" y="1251000"/>
-            <a:ext cx="5995080" cy="456480"/>
+            <a:ext cx="5994720" cy="456120"/>
           </a:xfrm>
           <a:prstGeom prst="rect">
             <a:avLst/>
@@ -21285,7 +21285,7 @@
         <p:spPr>
           <a:xfrm>
             <a:off x="335880" y="1889280"/>
-            <a:ext cx="6875640" cy="653760"/>
+            <a:ext cx="6875280" cy="653400"/>
           </a:xfrm>
           <a:prstGeom prst="rect">
             <a:avLst/>
@@ -21337,7 +21337,7 @@
         <p:spPr>
           <a:xfrm>
             <a:off x="340200" y="2682720"/>
-            <a:ext cx="6800400" cy="1955520"/>
+            <a:ext cx="6800040" cy="1955160"/>
           </a:xfrm>
           <a:custGeom>
             <a:avLst/>
@@ -21391,7 +21391,7 @@
         <p:spPr>
           <a:xfrm>
             <a:off x="512280" y="2854800"/>
-            <a:ext cx="6540120" cy="234000"/>
+            <a:ext cx="6539760" cy="233640"/>
           </a:xfrm>
           <a:prstGeom prst="rect">
             <a:avLst/>
@@ -21443,7 +21443,7 @@
         <p:spPr>
           <a:xfrm>
             <a:off x="512280" y="3190680"/>
-            <a:ext cx="6523200" cy="217080"/>
+            <a:ext cx="6522840" cy="216720"/>
           </a:xfrm>
           <a:prstGeom prst="rect">
             <a:avLst/>
@@ -21495,7 +21495,7 @@
         <p:spPr>
           <a:xfrm>
             <a:off x="512280" y="3509640"/>
-            <a:ext cx="6455880" cy="637200"/>
+            <a:ext cx="6455520" cy="636840"/>
           </a:xfrm>
           <a:custGeom>
             <a:avLst/>
@@ -21546,7 +21546,7 @@
         <p:spPr>
           <a:xfrm>
             <a:off x="613080" y="3610440"/>
-            <a:ext cx="6321600" cy="200520"/>
+            <a:ext cx="6321240" cy="200160"/>
           </a:xfrm>
           <a:prstGeom prst="rect">
             <a:avLst/>
@@ -21598,7 +21598,7 @@
         <p:spPr>
           <a:xfrm>
             <a:off x="613080" y="3845520"/>
-            <a:ext cx="6321600" cy="200520"/>
+            <a:ext cx="6321240" cy="200160"/>
           </a:xfrm>
           <a:prstGeom prst="rect">
             <a:avLst/>
@@ -21650,7 +21650,7 @@
         <p:spPr>
           <a:xfrm>
             <a:off x="512280" y="4248720"/>
-            <a:ext cx="6523200" cy="217080"/>
+            <a:ext cx="6522840" cy="216720"/>
           </a:xfrm>
           <a:prstGeom prst="rect">
             <a:avLst/>
@@ -21702,7 +21702,7 @@
         <p:spPr>
           <a:xfrm>
             <a:off x="352800" y="4777560"/>
-            <a:ext cx="6791760" cy="1527120"/>
+            <a:ext cx="6791400" cy="1526760"/>
           </a:xfrm>
           <a:custGeom>
             <a:avLst/>
@@ -21753,7 +21753,7 @@
         <p:spPr>
           <a:xfrm>
             <a:off x="352800" y="4777560"/>
-            <a:ext cx="32400" cy="1527120"/>
+            <a:ext cx="32040" cy="1526760"/>
           </a:xfrm>
           <a:custGeom>
             <a:avLst/>
@@ -21804,7 +21804,7 @@
         <p:spPr>
           <a:xfrm>
             <a:off x="537480" y="4945680"/>
-            <a:ext cx="6523200" cy="234000"/>
+            <a:ext cx="6522840" cy="233640"/>
           </a:xfrm>
           <a:prstGeom prst="rect">
             <a:avLst/>
@@ -21856,7 +21856,7 @@
         <p:spPr>
           <a:xfrm>
             <a:off x="537480" y="5281560"/>
-            <a:ext cx="6506280" cy="217080"/>
+            <a:ext cx="6505920" cy="216720"/>
           </a:xfrm>
           <a:prstGeom prst="rect">
             <a:avLst/>
@@ -21908,7 +21908,7 @@
         <p:spPr>
           <a:xfrm>
             <a:off x="537480" y="5600520"/>
-            <a:ext cx="3214800" cy="200520"/>
+            <a:ext cx="3214440" cy="200160"/>
           </a:xfrm>
           <a:prstGeom prst="rect">
             <a:avLst/>
@@ -21970,7 +21970,7 @@
         <p:spPr>
           <a:xfrm>
             <a:off x="3823200" y="5600520"/>
-            <a:ext cx="3214800" cy="200520"/>
+            <a:ext cx="3214440" cy="200160"/>
           </a:xfrm>
           <a:prstGeom prst="rect">
             <a:avLst/>
@@ -22032,7 +22032,7 @@
         <p:spPr>
           <a:xfrm>
             <a:off x="537480" y="5936400"/>
-            <a:ext cx="3214800" cy="200520"/>
+            <a:ext cx="3214440" cy="200160"/>
           </a:xfrm>
           <a:prstGeom prst="rect">
             <a:avLst/>
@@ -22094,7 +22094,7 @@
         <p:spPr>
           <a:xfrm>
             <a:off x="3823200" y="5936400"/>
-            <a:ext cx="3214800" cy="200520"/>
+            <a:ext cx="3214440" cy="200160"/>
           </a:xfrm>
           <a:prstGeom prst="rect">
             <a:avLst/>
@@ -22156,7 +22156,7 @@
         <p:spPr>
           <a:xfrm>
             <a:off x="7415640" y="1213200"/>
-            <a:ext cx="4440600" cy="3500280"/>
+            <a:ext cx="4440240" cy="3499920"/>
           </a:xfrm>
           <a:custGeom>
             <a:avLst/>
@@ -22210,7 +22210,7 @@
         <p:spPr>
           <a:xfrm>
             <a:off x="7587720" y="1385280"/>
-            <a:ext cx="4096440" cy="1678320"/>
+            <a:ext cx="4096080" cy="1677960"/>
           </a:xfrm>
           <a:prstGeom prst="roundRect">
             <a:avLst>
@@ -22242,7 +22242,7 @@
         <p:spPr>
           <a:xfrm>
             <a:off x="7545600" y="3199320"/>
-            <a:ext cx="4180320" cy="234000"/>
+            <a:ext cx="4179960" cy="233640"/>
           </a:xfrm>
           <a:prstGeom prst="rect">
             <a:avLst/>
@@ -22294,7 +22294,7 @@
         <p:spPr>
           <a:xfrm>
             <a:off x="7621200" y="3564360"/>
-            <a:ext cx="99720" cy="133200"/>
+            <a:ext cx="99360" cy="132840"/>
           </a:xfrm>
           <a:custGeom>
             <a:avLst/>
@@ -22493,7 +22493,7 @@
         <p:spPr>
           <a:xfrm>
             <a:off x="7800120" y="3534840"/>
-            <a:ext cx="3951360" cy="200520"/>
+            <a:ext cx="3951000" cy="200160"/>
           </a:xfrm>
           <a:prstGeom prst="rect">
             <a:avLst/>
@@ -22555,7 +22555,7 @@
         <p:spPr>
           <a:xfrm>
             <a:off x="7604640" y="3832920"/>
-            <a:ext cx="133200" cy="133200"/>
+            <a:ext cx="132840" cy="132840"/>
           </a:xfrm>
           <a:custGeom>
             <a:avLst/>
@@ -22762,7 +22762,7 @@
         <p:spPr>
           <a:xfrm>
             <a:off x="7800120" y="3803760"/>
-            <a:ext cx="3951360" cy="200520"/>
+            <a:ext cx="3951000" cy="200160"/>
           </a:xfrm>
           <a:prstGeom prst="rect">
             <a:avLst/>
@@ -22824,7 +22824,7 @@
         <p:spPr>
           <a:xfrm>
             <a:off x="7604640" y="4101840"/>
-            <a:ext cx="133200" cy="133200"/>
+            <a:ext cx="132840" cy="132840"/>
           </a:xfrm>
           <a:custGeom>
             <a:avLst/>
@@ -23015,7 +23015,7 @@
         <p:spPr>
           <a:xfrm>
             <a:off x="7800120" y="4072320"/>
-            <a:ext cx="3951360" cy="200520"/>
+            <a:ext cx="3951000" cy="200160"/>
           </a:xfrm>
           <a:prstGeom prst="rect">
             <a:avLst/>
@@ -23077,7 +23077,7 @@
         <p:spPr>
           <a:xfrm>
             <a:off x="7587720" y="4370400"/>
-            <a:ext cx="166680" cy="133200"/>
+            <a:ext cx="166320" cy="132840"/>
           </a:xfrm>
           <a:custGeom>
             <a:avLst/>
@@ -23293,7 +23293,7 @@
         <p:spPr>
           <a:xfrm>
             <a:off x="7800120" y="4341240"/>
-            <a:ext cx="3951360" cy="200520"/>
+            <a:ext cx="3951000" cy="200160"/>
           </a:xfrm>
           <a:prstGeom prst="rect">
             <a:avLst/>
@@ -23355,7 +23355,7 @@
         <p:spPr>
           <a:xfrm>
             <a:off x="7411320" y="4853160"/>
-            <a:ext cx="4449240" cy="1292040"/>
+            <a:ext cx="4448880" cy="1291680"/>
           </a:xfrm>
           <a:custGeom>
             <a:avLst/>
@@ -23406,7 +23406,7 @@
         <p:spPr>
           <a:xfrm>
             <a:off x="7579440" y="5021280"/>
-            <a:ext cx="4188960" cy="234000"/>
+            <a:ext cx="4188600" cy="233640"/>
           </a:xfrm>
           <a:prstGeom prst="rect">
             <a:avLst/>
@@ -23458,7 +23458,7 @@
         <p:spPr>
           <a:xfrm>
             <a:off x="7579440" y="5323680"/>
-            <a:ext cx="4180320" cy="653760"/>
+            <a:ext cx="4179960" cy="653400"/>
           </a:xfrm>
           <a:prstGeom prst="rect">
             <a:avLst/>
@@ -23547,7 +23547,7 @@
         <p:spPr>
           <a:xfrm>
             <a:off x="5486400" y="585720"/>
-            <a:ext cx="1218240" cy="18000"/>
+            <a:ext cx="1217880" cy="17640"/>
           </a:xfrm>
           <a:custGeom>
             <a:avLst/>
@@ -23598,7 +23598,7 @@
         <p:spPr>
           <a:xfrm>
             <a:off x="3664080" y="909720"/>
-            <a:ext cx="4866120" cy="1427760"/>
+            <a:ext cx="4865760" cy="1427400"/>
           </a:xfrm>
           <a:prstGeom prst="rect">
             <a:avLst/>
@@ -23671,7 +23671,7 @@
         <p:spPr>
           <a:xfrm>
             <a:off x="5486400" y="2643120"/>
-            <a:ext cx="1218240" cy="18000"/>
+            <a:ext cx="1217880" cy="17640"/>
           </a:xfrm>
           <a:custGeom>
             <a:avLst/>
@@ -23722,7 +23722,7 @@
         <p:spPr>
           <a:xfrm>
             <a:off x="1771560" y="2967120"/>
-            <a:ext cx="8647560" cy="1113480"/>
+            <a:ext cx="8647200" cy="1113120"/>
           </a:xfrm>
           <a:prstGeom prst="rect">
             <a:avLst/>
@@ -23774,7 +23774,7 @@
         <p:spPr>
           <a:xfrm>
             <a:off x="1781280" y="4309920"/>
-            <a:ext cx="8628480" cy="1237320"/>
+            <a:ext cx="8628120" cy="1236960"/>
           </a:xfrm>
           <a:prstGeom prst="rect">
             <a:avLst/>
@@ -23826,7 +23826,7 @@
         <p:spPr>
           <a:xfrm>
             <a:off x="2615400" y="6005520"/>
-            <a:ext cx="6961680" cy="265680"/>
+            <a:ext cx="6961320" cy="265320"/>
           </a:xfrm>
           <a:prstGeom prst="rect">
             <a:avLst/>
@@ -23915,7 +23915,7 @@
         <p:spPr>
           <a:xfrm>
             <a:off x="609480" y="1781280"/>
-            <a:ext cx="12191040" cy="1218240"/>
+            <a:ext cx="12190680" cy="1217880"/>
           </a:xfrm>
           <a:prstGeom prst="rect">
             <a:avLst/>
@@ -23969,7 +23969,7 @@
         <p:spPr>
           <a:xfrm>
             <a:off x="609480" y="3152880"/>
-            <a:ext cx="11867040" cy="1141920"/>
+            <a:ext cx="11866680" cy="1141560"/>
           </a:xfrm>
           <a:prstGeom prst="rect">
             <a:avLst/>
@@ -24042,7 +24042,7 @@
         <p:spPr>
           <a:xfrm>
             <a:off x="609480" y="4524480"/>
-            <a:ext cx="1218240" cy="18000"/>
+            <a:ext cx="1217880" cy="17640"/>
           </a:xfrm>
           <a:custGeom>
             <a:avLst/>
@@ -24093,7 +24093,7 @@
         <p:spPr>
           <a:xfrm>
             <a:off x="609480" y="4772160"/>
-            <a:ext cx="11695680" cy="303840"/>
+            <a:ext cx="11695320" cy="303480"/>
           </a:xfrm>
           <a:prstGeom prst="rect">
             <a:avLst/>
@@ -24182,7 +24182,7 @@
         <p:spPr>
           <a:xfrm>
             <a:off x="380880" y="380880"/>
-            <a:ext cx="11505240" cy="227520"/>
+            <a:ext cx="11504880" cy="227160"/>
           </a:xfrm>
           <a:prstGeom prst="rect">
             <a:avLst/>
@@ -24210,7 +24210,7 @@
               <a:buNone/>
             </a:pPr>
             <a:r>
-              <a:rPr b="1" lang="en-US" sz="1200" spc="52" strike="noStrike">
+              <a:rPr b="1" lang="en-US" sz="1200" spc="49" strike="noStrike">
                 <a:solidFill>
                   <a:srgbClr val="0984e3"/>
                 </a:solidFill>
@@ -24234,7 +24234,7 @@
         <p:spPr>
           <a:xfrm>
             <a:off x="380880" y="685800"/>
-            <a:ext cx="11657520" cy="456120"/>
+            <a:ext cx="11657160" cy="455760"/>
           </a:xfrm>
           <a:prstGeom prst="rect">
             <a:avLst/>
@@ -24286,7 +24286,7 @@
         <p:spPr>
           <a:xfrm>
             <a:off x="380880" y="1371600"/>
-            <a:ext cx="6828480" cy="1237320"/>
+            <a:ext cx="6828120" cy="1236960"/>
           </a:xfrm>
           <a:prstGeom prst="rect">
             <a:avLst/>
@@ -24314,29 +24314,38 @@
               <a:buNone/>
             </a:pPr>
             <a:r>
-              <a:rPr b="1" lang="en-US" sz="1500" spc="-1" strike="noStrike">
+              <a:rPr b="1" i="1" lang="en-US" sz="1500" spc="-1" strike="noStrike">
                 <a:solidFill>
                   <a:srgbClr val="00008b"/>
                 </a:solidFill>
+                <a:highlight>
+                  <a:srgbClr val="ffff00"/>
+                </a:highlight>
                 <a:latin typeface="Quattrocento Sans"/>
                 <a:ea typeface="Quattrocento Sans"/>
               </a:rPr>
               <a:t>Game theory is a mathematical framework for analyzing strategic interactions among rational decision-makers.</a:t>
             </a:r>
             <a:r>
-              <a:rPr b="0" lang="en-US" sz="1500" spc="-1" strike="noStrike">
+              <a:rPr b="0" i="1" lang="en-US" sz="1500" spc="-1" strike="noStrike">
                 <a:solidFill>
                   <a:srgbClr val="00008b"/>
                 </a:solidFill>
+                <a:highlight>
+                  <a:srgbClr val="ffff00"/>
+                </a:highlight>
                 <a:latin typeface="Quattrocento Sans"/>
                 <a:ea typeface="Quattrocento Sans"/>
               </a:rPr>
               <a:t> It provides a structured approach to understanding how individuals or groups make decisions in situations where the outcome depends on the choices of multiple participants.</a:t>
             </a:r>
-            <a:endParaRPr b="0" lang="en-HK" sz="1500" spc="-1" strike="noStrike">
+            <a:endParaRPr b="0" i="1" lang="en-HK" sz="1500" spc="-1" strike="noStrike">
               <a:solidFill>
                 <a:srgbClr val="00008b"/>
               </a:solidFill>
+              <a:highlight>
+                <a:srgbClr val="ffff00"/>
+              </a:highlight>
               <a:latin typeface="Arial"/>
             </a:endParaRPr>
           </a:p>
@@ -24351,7 +24360,7 @@
         <p:spPr>
           <a:xfrm>
             <a:off x="380880" y="2838600"/>
-            <a:ext cx="6818760" cy="1113480"/>
+            <a:ext cx="6818400" cy="1113120"/>
           </a:xfrm>
           <a:prstGeom prst="rect">
             <a:avLst/>
@@ -24403,7 +24412,7 @@
         <p:spPr>
           <a:xfrm>
             <a:off x="399960" y="4986360"/>
-            <a:ext cx="6714000" cy="1361160"/>
+            <a:ext cx="6713640" cy="1360800"/>
           </a:xfrm>
           <a:custGeom>
             <a:avLst/>
@@ -24454,7 +24463,7 @@
         <p:spPr>
           <a:xfrm>
             <a:off x="399960" y="4986360"/>
-            <a:ext cx="37080" cy="1361160"/>
+            <a:ext cx="36720" cy="1360800"/>
           </a:xfrm>
           <a:custGeom>
             <a:avLst/>
@@ -24505,7 +24514,7 @@
         <p:spPr>
           <a:xfrm>
             <a:off x="647640" y="5214960"/>
-            <a:ext cx="6323400" cy="560880"/>
+            <a:ext cx="6323040" cy="560520"/>
           </a:xfrm>
           <a:prstGeom prst="rect">
             <a:avLst/>
@@ -24557,7 +24566,7 @@
         <p:spPr>
           <a:xfrm>
             <a:off x="647640" y="5886360"/>
-            <a:ext cx="6314040" cy="227520"/>
+            <a:ext cx="6313680" cy="227160"/>
           </a:xfrm>
           <a:prstGeom prst="rect">
             <a:avLst/>
@@ -24619,7 +24628,7 @@
         <p:spPr>
           <a:xfrm>
             <a:off x="7426440" y="1376280"/>
-            <a:ext cx="4380480" cy="1494360"/>
+            <a:ext cx="4380120" cy="1494000"/>
           </a:xfrm>
           <a:custGeom>
             <a:avLst/>
@@ -24673,7 +24682,7 @@
         <p:spPr>
           <a:xfrm>
             <a:off x="7660080" y="1609560"/>
-            <a:ext cx="379800" cy="379800"/>
+            <a:ext cx="379440" cy="379440"/>
           </a:xfrm>
           <a:custGeom>
             <a:avLst/>
@@ -24724,7 +24733,7 @@
         <p:spPr>
           <a:xfrm>
             <a:off x="7745760" y="1714680"/>
-            <a:ext cx="213120" cy="170280"/>
+            <a:ext cx="212760" cy="169920"/>
           </a:xfrm>
           <a:custGeom>
             <a:avLst/>
@@ -24940,7 +24949,7 @@
         <p:spPr>
           <a:xfrm>
             <a:off x="8155440" y="1666800"/>
-            <a:ext cx="637200" cy="265680"/>
+            <a:ext cx="636840" cy="265320"/>
           </a:xfrm>
           <a:prstGeom prst="rect">
             <a:avLst/>
@@ -24992,7 +25001,7 @@
         <p:spPr>
           <a:xfrm>
             <a:off x="7660080" y="2143080"/>
-            <a:ext cx="3989880" cy="494280"/>
+            <a:ext cx="3989520" cy="493920"/>
           </a:xfrm>
           <a:prstGeom prst="rect">
             <a:avLst/>
@@ -25044,7 +25053,7 @@
         <p:spPr>
           <a:xfrm>
             <a:off x="7426440" y="3110040"/>
-            <a:ext cx="4380480" cy="1494360"/>
+            <a:ext cx="4380120" cy="1494000"/>
           </a:xfrm>
           <a:custGeom>
             <a:avLst/>
@@ -25098,7 +25107,7 @@
         <p:spPr>
           <a:xfrm>
             <a:off x="7660080" y="3343320"/>
-            <a:ext cx="379800" cy="379800"/>
+            <a:ext cx="379440" cy="379440"/>
           </a:xfrm>
           <a:custGeom>
             <a:avLst/>
@@ -25149,7 +25158,7 @@
         <p:spPr>
           <a:xfrm>
             <a:off x="7767000" y="3448080"/>
-            <a:ext cx="170280" cy="170280"/>
+            <a:ext cx="169920" cy="169920"/>
           </a:xfrm>
           <a:custGeom>
             <a:avLst/>
@@ -25425,7 +25434,7 @@
         <p:spPr>
           <a:xfrm>
             <a:off x="8155440" y="3400560"/>
-            <a:ext cx="865800" cy="265680"/>
+            <a:ext cx="865440" cy="265320"/>
           </a:xfrm>
           <a:prstGeom prst="rect">
             <a:avLst/>
@@ -25477,7 +25486,7 @@
         <p:spPr>
           <a:xfrm>
             <a:off x="7660080" y="3876840"/>
-            <a:ext cx="3989880" cy="494280"/>
+            <a:ext cx="3989520" cy="493920"/>
           </a:xfrm>
           <a:prstGeom prst="rect">
             <a:avLst/>
@@ -25529,7 +25538,7 @@
         <p:spPr>
           <a:xfrm>
             <a:off x="7426440" y="4843440"/>
-            <a:ext cx="4380480" cy="1494360"/>
+            <a:ext cx="4380120" cy="1494000"/>
           </a:xfrm>
           <a:custGeom>
             <a:avLst/>
@@ -25583,7 +25592,7 @@
         <p:spPr>
           <a:xfrm>
             <a:off x="7660080" y="5076720"/>
-            <a:ext cx="379800" cy="379800"/>
+            <a:ext cx="379440" cy="379440"/>
           </a:xfrm>
           <a:custGeom>
             <a:avLst/>
@@ -25634,7 +25643,7 @@
         <p:spPr>
           <a:xfrm>
             <a:off x="7767000" y="5181480"/>
-            <a:ext cx="170280" cy="170280"/>
+            <a:ext cx="169920" cy="169920"/>
           </a:xfrm>
           <a:custGeom>
             <a:avLst/>
@@ -25811,7 +25820,7 @@
         <p:spPr>
           <a:xfrm>
             <a:off x="8155440" y="5133960"/>
-            <a:ext cx="656280" cy="265680"/>
+            <a:ext cx="655920" cy="265320"/>
           </a:xfrm>
           <a:prstGeom prst="rect">
             <a:avLst/>
@@ -25863,7 +25872,7 @@
         <p:spPr>
           <a:xfrm>
             <a:off x="7660080" y="5610240"/>
-            <a:ext cx="3989880" cy="494280"/>
+            <a:ext cx="3989520" cy="493920"/>
           </a:xfrm>
           <a:prstGeom prst="rect">
             <a:avLst/>
@@ -25952,7 +25961,7 @@
         <p:spPr>
           <a:xfrm>
             <a:off x="609480" y="1781280"/>
-            <a:ext cx="12191040" cy="1218240"/>
+            <a:ext cx="12190680" cy="1217880"/>
           </a:xfrm>
           <a:prstGeom prst="rect">
             <a:avLst/>
@@ -26006,7 +26015,7 @@
         <p:spPr>
           <a:xfrm>
             <a:off x="609480" y="3152880"/>
-            <a:ext cx="11867040" cy="1141920"/>
+            <a:ext cx="11866680" cy="1141560"/>
           </a:xfrm>
           <a:prstGeom prst="rect">
             <a:avLst/>
@@ -26079,7 +26088,7 @@
         <p:spPr>
           <a:xfrm>
             <a:off x="609480" y="4524480"/>
-            <a:ext cx="1218240" cy="18000"/>
+            <a:ext cx="1217880" cy="17640"/>
           </a:xfrm>
           <a:custGeom>
             <a:avLst/>
@@ -26130,7 +26139,7 @@
         <p:spPr>
           <a:xfrm>
             <a:off x="609480" y="4772160"/>
-            <a:ext cx="11695680" cy="303840"/>
+            <a:ext cx="11695320" cy="303480"/>
           </a:xfrm>
           <a:prstGeom prst="rect">
             <a:avLst/>
@@ -26219,7 +26228,7 @@
         <p:spPr>
           <a:xfrm>
             <a:off x="324360" y="324360"/>
-            <a:ext cx="11607120" cy="193320"/>
+            <a:ext cx="11606760" cy="192960"/>
           </a:xfrm>
           <a:prstGeom prst="rect">
             <a:avLst/>
@@ -26247,7 +26256,7 @@
               <a:buNone/>
             </a:pPr>
             <a:r>
-              <a:rPr b="1" lang="en-US" sz="1020" spc="43" strike="noStrike">
+              <a:rPr b="1" lang="en-US" sz="1020" spc="41" strike="noStrike">
                 <a:solidFill>
                   <a:srgbClr val="0984e3"/>
                 </a:solidFill>
@@ -26271,7 +26280,7 @@
         <p:spPr>
           <a:xfrm>
             <a:off x="324360" y="583560"/>
-            <a:ext cx="11737080" cy="388080"/>
+            <a:ext cx="11736720" cy="387720"/>
           </a:xfrm>
           <a:prstGeom prst="rect">
             <a:avLst/>
@@ -26323,7 +26332,7 @@
         <p:spPr>
           <a:xfrm>
             <a:off x="6095880" y="1167480"/>
-            <a:ext cx="15120" cy="4976280"/>
+            <a:ext cx="14760" cy="4975920"/>
           </a:xfrm>
           <a:custGeom>
             <a:avLst/>
@@ -26374,7 +26383,7 @@
         <p:spPr>
           <a:xfrm>
             <a:off x="1638000" y="1171440"/>
-            <a:ext cx="3865680" cy="720360"/>
+            <a:ext cx="3865320" cy="720000"/>
           </a:xfrm>
           <a:custGeom>
             <a:avLst/>
@@ -26428,7 +26437,7 @@
         <p:spPr>
           <a:xfrm>
             <a:off x="1698840" y="1305000"/>
-            <a:ext cx="3671280" cy="225720"/>
+            <a:ext cx="3670920" cy="225360"/>
           </a:xfrm>
           <a:prstGeom prst="rect">
             <a:avLst/>
@@ -26480,7 +26489,7 @@
         <p:spPr>
           <a:xfrm>
             <a:off x="1706760" y="1564560"/>
-            <a:ext cx="3663000" cy="193320"/>
+            <a:ext cx="3662640" cy="192960"/>
           </a:xfrm>
           <a:prstGeom prst="rect">
             <a:avLst/>
@@ -26532,7 +26541,7 @@
         <p:spPr>
           <a:xfrm>
             <a:off x="6683760" y="2030760"/>
-            <a:ext cx="3290040" cy="720360"/>
+            <a:ext cx="3289680" cy="720000"/>
           </a:xfrm>
           <a:custGeom>
             <a:avLst/>
@@ -26586,7 +26595,7 @@
         <p:spPr>
           <a:xfrm>
             <a:off x="6817320" y="2164320"/>
-            <a:ext cx="3095640" cy="225720"/>
+            <a:ext cx="3095280" cy="225360"/>
           </a:xfrm>
           <a:prstGeom prst="rect">
             <a:avLst/>
@@ -26638,7 +26647,7 @@
         <p:spPr>
           <a:xfrm>
             <a:off x="6817320" y="2423880"/>
-            <a:ext cx="3087360" cy="193320"/>
+            <a:ext cx="3087000" cy="192960"/>
           </a:xfrm>
           <a:prstGeom prst="rect">
             <a:avLst/>
@@ -26690,7 +26699,7 @@
         <p:spPr>
           <a:xfrm>
             <a:off x="633600" y="2885760"/>
-            <a:ext cx="4879080" cy="712440"/>
+            <a:ext cx="4878720" cy="712080"/>
           </a:xfrm>
           <a:custGeom>
             <a:avLst/>
@@ -26741,7 +26750,7 @@
         <p:spPr>
           <a:xfrm>
             <a:off x="633600" y="2885760"/>
-            <a:ext cx="31320" cy="712440"/>
+            <a:ext cx="30960" cy="712080"/>
           </a:xfrm>
           <a:custGeom>
             <a:avLst/>
@@ -26792,7 +26801,7 @@
         <p:spPr>
           <a:xfrm>
             <a:off x="706680" y="3015720"/>
-            <a:ext cx="4676400" cy="225720"/>
+            <a:ext cx="4676040" cy="225360"/>
           </a:xfrm>
           <a:prstGeom prst="rect">
             <a:avLst/>
@@ -26844,7 +26853,7 @@
         <p:spPr>
           <a:xfrm>
             <a:off x="714960" y="3274920"/>
-            <a:ext cx="4668120" cy="193320"/>
+            <a:ext cx="4667760" cy="192960"/>
           </a:xfrm>
           <a:prstGeom prst="rect">
             <a:avLst/>
@@ -26906,7 +26915,7 @@
         <p:spPr>
           <a:xfrm>
             <a:off x="6696000" y="3728880"/>
-            <a:ext cx="5016600" cy="712440"/>
+            <a:ext cx="5016240" cy="712080"/>
           </a:xfrm>
           <a:custGeom>
             <a:avLst/>
@@ -26957,7 +26966,7 @@
         <p:spPr>
           <a:xfrm>
             <a:off x="6696000" y="3728880"/>
-            <a:ext cx="31320" cy="712440"/>
+            <a:ext cx="30960" cy="712080"/>
           </a:xfrm>
           <a:custGeom>
             <a:avLst/>
@@ -27008,7 +27017,7 @@
         <p:spPr>
           <a:xfrm>
             <a:off x="6841800" y="3858480"/>
-            <a:ext cx="4814280" cy="225720"/>
+            <a:ext cx="4813920" cy="225360"/>
           </a:xfrm>
           <a:prstGeom prst="rect">
             <a:avLst/>
@@ -27060,7 +27069,7 @@
         <p:spPr>
           <a:xfrm>
             <a:off x="6841800" y="4118040"/>
-            <a:ext cx="4806000" cy="193320"/>
+            <a:ext cx="4805640" cy="192960"/>
           </a:xfrm>
           <a:prstGeom prst="rect">
             <a:avLst/>
@@ -27122,7 +27131,7 @@
         <p:spPr>
           <a:xfrm>
             <a:off x="1476360" y="4572000"/>
-            <a:ext cx="4035960" cy="712440"/>
+            <a:ext cx="4035600" cy="712080"/>
           </a:xfrm>
           <a:custGeom>
             <a:avLst/>
@@ -27173,7 +27182,7 @@
         <p:spPr>
           <a:xfrm>
             <a:off x="1532880" y="4701600"/>
-            <a:ext cx="3849480" cy="225720"/>
+            <a:ext cx="3849120" cy="225360"/>
           </a:xfrm>
           <a:prstGeom prst="rect">
             <a:avLst/>
@@ -27225,7 +27234,7 @@
         <p:spPr>
           <a:xfrm>
             <a:off x="1541160" y="4961160"/>
-            <a:ext cx="3841200" cy="193320"/>
+            <a:ext cx="3840840" cy="192960"/>
           </a:xfrm>
           <a:prstGeom prst="rect">
             <a:avLst/>
@@ -27287,7 +27296,7 @@
         <p:spPr>
           <a:xfrm>
             <a:off x="6683760" y="5419080"/>
-            <a:ext cx="3987360" cy="720360"/>
+            <a:ext cx="3987000" cy="720000"/>
           </a:xfrm>
           <a:custGeom>
             <a:avLst/>
@@ -27341,7 +27350,7 @@
         <p:spPr>
           <a:xfrm>
             <a:off x="6817320" y="5553000"/>
-            <a:ext cx="3792600" cy="225720"/>
+            <a:ext cx="3792240" cy="225360"/>
           </a:xfrm>
           <a:prstGeom prst="rect">
             <a:avLst/>
@@ -27393,7 +27402,7 @@
         <p:spPr>
           <a:xfrm>
             <a:off x="6817320" y="5812200"/>
-            <a:ext cx="3784680" cy="193320"/>
+            <a:ext cx="3784320" cy="192960"/>
           </a:xfrm>
           <a:prstGeom prst="rect">
             <a:avLst/>
@@ -27445,7 +27454,7 @@
         <p:spPr>
           <a:xfrm>
             <a:off x="6031080" y="1467360"/>
-            <a:ext cx="128520" cy="128520"/>
+            <a:ext cx="128160" cy="128160"/>
           </a:xfrm>
           <a:custGeom>
             <a:avLst/>
@@ -27516,7 +27525,7 @@
         <p:spPr>
           <a:xfrm>
             <a:off x="6031080" y="2326680"/>
-            <a:ext cx="128520" cy="128520"/>
+            <a:ext cx="128160" cy="128160"/>
           </a:xfrm>
           <a:custGeom>
             <a:avLst/>
@@ -27587,7 +27596,7 @@
         <p:spPr>
           <a:xfrm>
             <a:off x="6031080" y="3177720"/>
-            <a:ext cx="128520" cy="128520"/>
+            <a:ext cx="128160" cy="128160"/>
           </a:xfrm>
           <a:custGeom>
             <a:avLst/>
@@ -27658,7 +27667,7 @@
         <p:spPr>
           <a:xfrm>
             <a:off x="6031080" y="4020840"/>
-            <a:ext cx="128520" cy="128520"/>
+            <a:ext cx="128160" cy="128160"/>
           </a:xfrm>
           <a:custGeom>
             <a:avLst/>
@@ -27729,7 +27738,7 @@
         <p:spPr>
           <a:xfrm>
             <a:off x="6031080" y="4863960"/>
-            <a:ext cx="128520" cy="128520"/>
+            <a:ext cx="128160" cy="128160"/>
           </a:xfrm>
           <a:custGeom>
             <a:avLst/>
@@ -27800,7 +27809,7 @@
         <p:spPr>
           <a:xfrm>
             <a:off x="6031080" y="5715000"/>
-            <a:ext cx="128520" cy="128520"/>
+            <a:ext cx="128160" cy="128160"/>
           </a:xfrm>
           <a:custGeom>
             <a:avLst/>
@@ -27908,7 +27917,7 @@
         <p:spPr>
           <a:xfrm>
             <a:off x="380880" y="380880"/>
-            <a:ext cx="11505240" cy="227520"/>
+            <a:ext cx="11504880" cy="227160"/>
           </a:xfrm>
           <a:prstGeom prst="rect">
             <a:avLst/>
@@ -27936,7 +27945,7 @@
               <a:buNone/>
             </a:pPr>
             <a:r>
-              <a:rPr b="1" lang="en-US" sz="1200" spc="52" strike="noStrike">
+              <a:rPr b="1" lang="en-US" sz="1200" spc="49" strike="noStrike">
                 <a:solidFill>
                   <a:srgbClr val="0984e3"/>
                 </a:solidFill>
@@ -27960,7 +27969,7 @@
         <p:spPr>
           <a:xfrm>
             <a:off x="380880" y="685800"/>
-            <a:ext cx="11657520" cy="456120"/>
+            <a:ext cx="11657160" cy="455760"/>
           </a:xfrm>
           <a:prstGeom prst="rect">
             <a:avLst/>
@@ -28012,7 +28021,7 @@
         <p:spPr>
           <a:xfrm>
             <a:off x="380880" y="1371600"/>
-            <a:ext cx="4389840" cy="3047040"/>
+            <a:ext cx="4389480" cy="3046680"/>
           </a:xfrm>
           <a:prstGeom prst="roundRect">
             <a:avLst>
@@ -28044,7 +28053,7 @@
         <p:spPr>
           <a:xfrm>
             <a:off x="399960" y="4648320"/>
-            <a:ext cx="4370760" cy="1141920"/>
+            <a:ext cx="4370400" cy="1141560"/>
           </a:xfrm>
           <a:custGeom>
             <a:avLst/>
@@ -28095,7 +28104,7 @@
         <p:spPr>
           <a:xfrm>
             <a:off x="399960" y="4648320"/>
-            <a:ext cx="37080" cy="1141920"/>
+            <a:ext cx="36720" cy="1141560"/>
           </a:xfrm>
           <a:custGeom>
             <a:avLst/>
@@ -28146,7 +28155,7 @@
         <p:spPr>
           <a:xfrm>
             <a:off x="609480" y="4838760"/>
-            <a:ext cx="4047120" cy="494280"/>
+            <a:ext cx="4046760" cy="493920"/>
           </a:xfrm>
           <a:prstGeom prst="rect">
             <a:avLst/>
@@ -28198,7 +28207,7 @@
         <p:spPr>
           <a:xfrm>
             <a:off x="609480" y="5410080"/>
-            <a:ext cx="4037400" cy="189360"/>
+            <a:ext cx="4037040" cy="189000"/>
           </a:xfrm>
           <a:prstGeom prst="rect">
             <a:avLst/>
@@ -28260,7 +28269,7 @@
         <p:spPr>
           <a:xfrm>
             <a:off x="5074920" y="1371600"/>
-            <a:ext cx="6847560" cy="303840"/>
+            <a:ext cx="6847200" cy="303480"/>
           </a:xfrm>
           <a:prstGeom prst="rect">
             <a:avLst/>
@@ -28312,7 +28321,7 @@
         <p:spPr>
           <a:xfrm>
             <a:off x="5074920" y="1752480"/>
-            <a:ext cx="6809400" cy="989640"/>
+            <a:ext cx="6809040" cy="989280"/>
           </a:xfrm>
           <a:prstGeom prst="rect">
             <a:avLst/>
@@ -28364,7 +28373,7 @@
         <p:spPr>
           <a:xfrm>
             <a:off x="5074920" y="2895480"/>
-            <a:ext cx="6847560" cy="303840"/>
+            <a:ext cx="6847200" cy="303480"/>
           </a:xfrm>
           <a:prstGeom prst="rect">
             <a:avLst/>
@@ -28416,7 +28425,7 @@
         <p:spPr>
           <a:xfrm>
             <a:off x="5074920" y="3276720"/>
-            <a:ext cx="6809400" cy="989640"/>
+            <a:ext cx="6809040" cy="989280"/>
           </a:xfrm>
           <a:prstGeom prst="rect">
             <a:avLst/>
@@ -28488,7 +28497,7 @@
         <p:spPr>
           <a:xfrm>
             <a:off x="5074920" y="4419720"/>
-            <a:ext cx="6847560" cy="303840"/>
+            <a:ext cx="6847200" cy="303480"/>
           </a:xfrm>
           <a:prstGeom prst="rect">
             <a:avLst/>
@@ -28540,7 +28549,7 @@
         <p:spPr>
           <a:xfrm>
             <a:off x="5074920" y="4800600"/>
-            <a:ext cx="6809400" cy="989640"/>
+            <a:ext cx="6809040" cy="989280"/>
           </a:xfrm>
           <a:prstGeom prst="rect">
             <a:avLst/>
@@ -28649,7 +28658,7 @@
         <p:spPr>
           <a:xfrm>
             <a:off x="609480" y="1781280"/>
-            <a:ext cx="12191040" cy="1218240"/>
+            <a:ext cx="12190680" cy="1217880"/>
           </a:xfrm>
           <a:prstGeom prst="rect">
             <a:avLst/>
@@ -28703,7 +28712,7 @@
         <p:spPr>
           <a:xfrm>
             <a:off x="609480" y="3152880"/>
-            <a:ext cx="11867040" cy="1141920"/>
+            <a:ext cx="11866680" cy="1141560"/>
           </a:xfrm>
           <a:prstGeom prst="rect">
             <a:avLst/>
@@ -28776,7 +28785,7 @@
         <p:spPr>
           <a:xfrm>
             <a:off x="609480" y="4524480"/>
-            <a:ext cx="1218240" cy="18000"/>
+            <a:ext cx="1217880" cy="17640"/>
           </a:xfrm>
           <a:custGeom>
             <a:avLst/>
@@ -28827,7 +28836,7 @@
         <p:spPr>
           <a:xfrm>
             <a:off x="609480" y="4772160"/>
-            <a:ext cx="11695680" cy="303840"/>
+            <a:ext cx="11695320" cy="303480"/>
           </a:xfrm>
           <a:prstGeom prst="rect">
             <a:avLst/>
@@ -28916,7 +28925,7 @@
         <p:spPr>
           <a:xfrm>
             <a:off x="380880" y="380880"/>
-            <a:ext cx="11505240" cy="227520"/>
+            <a:ext cx="11504880" cy="227160"/>
           </a:xfrm>
           <a:prstGeom prst="rect">
             <a:avLst/>
@@ -28944,7 +28953,7 @@
               <a:buNone/>
             </a:pPr>
             <a:r>
-              <a:rPr b="1" lang="en-US" sz="1200" spc="52" strike="noStrike">
+              <a:rPr b="1" lang="en-US" sz="1200" spc="49" strike="noStrike">
                 <a:solidFill>
                   <a:srgbClr val="0984e3"/>
                 </a:solidFill>
@@ -28968,7 +28977,7 @@
         <p:spPr>
           <a:xfrm>
             <a:off x="380880" y="685800"/>
-            <a:ext cx="11657520" cy="456120"/>
+            <a:ext cx="11657160" cy="455760"/>
           </a:xfrm>
           <a:prstGeom prst="rect">
             <a:avLst/>
@@ -29020,7 +29029,7 @@
         <p:spPr>
           <a:xfrm>
             <a:off x="380880" y="1371600"/>
-            <a:ext cx="5656680" cy="1237320"/>
+            <a:ext cx="5656320" cy="1236960"/>
           </a:xfrm>
           <a:prstGeom prst="rect">
             <a:avLst/>
@@ -29082,7 +29091,7 @@
         <p:spPr>
           <a:xfrm>
             <a:off x="380880" y="2762280"/>
-            <a:ext cx="5647320" cy="837000"/>
+            <a:ext cx="5646960" cy="836640"/>
           </a:xfrm>
           <a:prstGeom prst="rect">
             <a:avLst/>
@@ -29134,7 +29143,7 @@
         <p:spPr>
           <a:xfrm>
             <a:off x="399960" y="3750480"/>
-            <a:ext cx="5542560" cy="1599120"/>
+            <a:ext cx="5542200" cy="1598760"/>
           </a:xfrm>
           <a:custGeom>
             <a:avLst/>
@@ -29185,7 +29194,7 @@
         <p:spPr>
           <a:xfrm>
             <a:off x="399960" y="3750480"/>
-            <a:ext cx="37080" cy="1599120"/>
+            <a:ext cx="36720" cy="1598760"/>
           </a:xfrm>
           <a:custGeom>
             <a:avLst/>
@@ -29236,7 +29245,7 @@
         <p:spPr>
           <a:xfrm>
             <a:off x="609480" y="3940920"/>
-            <a:ext cx="5237640" cy="265680"/>
+            <a:ext cx="5237280" cy="265320"/>
           </a:xfrm>
           <a:prstGeom prst="rect">
             <a:avLst/>
@@ -29288,7 +29297,7 @@
         <p:spPr>
           <a:xfrm>
             <a:off x="609480" y="4321800"/>
-            <a:ext cx="5218560" cy="227520"/>
+            <a:ext cx="5218200" cy="227160"/>
           </a:xfrm>
           <a:prstGeom prst="rect">
             <a:avLst/>
@@ -29350,7 +29359,7 @@
         <p:spPr>
           <a:xfrm>
             <a:off x="609480" y="4626720"/>
-            <a:ext cx="5218560" cy="227520"/>
+            <a:ext cx="5218200" cy="227160"/>
           </a:xfrm>
           <a:prstGeom prst="rect">
             <a:avLst/>
@@ -29412,7 +29421,7 @@
         <p:spPr>
           <a:xfrm>
             <a:off x="609480" y="4931640"/>
-            <a:ext cx="5218560" cy="227520"/>
+            <a:ext cx="5218200" cy="227160"/>
           </a:xfrm>
           <a:prstGeom prst="rect">
             <a:avLst/>
@@ -29474,7 +29483,7 @@
         <p:spPr>
           <a:xfrm>
             <a:off x="6253200" y="1618200"/>
-            <a:ext cx="5551920" cy="3485160"/>
+            <a:ext cx="5551560" cy="3484800"/>
           </a:xfrm>
           <a:custGeom>
             <a:avLst/>
@@ -29528,7 +29537,7 @@
         <p:spPr>
           <a:xfrm>
             <a:off x="6438960" y="1851480"/>
-            <a:ext cx="5180400" cy="265680"/>
+            <a:ext cx="5180040" cy="265320"/>
           </a:xfrm>
           <a:prstGeom prst="rect">
             <a:avLst/>
@@ -29580,7 +29589,7 @@
         <p:spPr>
           <a:xfrm>
             <a:off x="6448320" y="2270520"/>
-            <a:ext cx="5161320" cy="227520"/>
+            <a:ext cx="5160960" cy="227160"/>
           </a:xfrm>
           <a:prstGeom prst="rect">
             <a:avLst/>
@@ -30104,7 +30113,7 @@
         <p:spPr>
           <a:xfrm>
             <a:off x="6486480" y="4218480"/>
-            <a:ext cx="5085360" cy="8280"/>
+            <a:ext cx="5085000" cy="7920"/>
           </a:xfrm>
           <a:custGeom>
             <a:avLst/>
@@ -30155,7 +30164,7 @@
         <p:spPr>
           <a:xfrm>
             <a:off x="6486480" y="4375440"/>
-            <a:ext cx="5161320" cy="494280"/>
+            <a:ext cx="5160960" cy="493920"/>
           </a:xfrm>
           <a:prstGeom prst="rect">
             <a:avLst/>

</xml_diff>